<commit_message>
fix(templates): rotate image-led reference assets
</commit_message>
<xml_diff>
--- a/skills/presentation-template-library/skills/artifact-template-aqua-impact-story/assets/reference.pptx
+++ b/skills/presentation-template-library/skills/artifact-template-aqua-impact-story/assets/reference.pptx
@@ -351,161 +351,19 @@
 </c:chartSpace>
 </file>
 
-<file path=ppt/slides/charts/chart2.xml><?xml version="1.0" encoding="utf-8"?>
-<c:chartSpace xmlns:c="http://schemas.openxmlformats.org/drawingml/2006/chart" xmlns:a="http://schemas.openxmlformats.org/drawingml/2006/main">
-  <c:chart>
-    <c:title>
-      <c:tx>
-        <c:rich>
-          <a:bodyPr/>
-          <a:lstStyle/>
-          <a:p>
-            <a:r>
-              <a:t>Signal carried by the evidence</a:t>
-            </a:r>
-          </a:p>
-        </c:rich>
-      </c:tx>
-      <c:layout/>
-    </c:title>
-    <c:plotArea>
-      <c:layout/>
-      <c:lineChart>
-        <c:grouping val="standard"/>
-        <c:ser>
-          <c:idx val="0"/>
-          <c:order val="0"/>
-          <c:tx>
-            <c:v>Observed</c:v>
-          </c:tx>
-          <c:spPr>
-            <a:solidFill>
-              <a:srgbClr val="0B8EA3"/>
-            </a:solidFill>
-          </c:spPr>
-          <c:cat>
-            <c:strLit>
-              <c:ptCount val="5"/>
-              <c:pt idx="0">
-                <c:v>A</c:v>
-              </c:pt>
-              <c:pt idx="1">
-                <c:v>B</c:v>
-              </c:pt>
-              <c:pt idx="2">
-                <c:v>C</c:v>
-              </c:pt>
-              <c:pt idx="3">
-                <c:v>D</c:v>
-              </c:pt>
-              <c:pt idx="4">
-                <c:v>E</c:v>
-              </c:pt>
-            </c:strLit>
-          </c:cat>
-          <c:val>
-            <c:numLit>
-              <c:formatCode>General</c:formatCode>
-              <c:ptCount val="5"/>
-              <c:pt idx="0">
-                <c:v>38</c:v>
-              </c:pt>
-              <c:pt idx="1">
-                <c:v>46</c:v>
-              </c:pt>
-              <c:pt idx="2">
-                <c:v>43</c:v>
-              </c:pt>
-              <c:pt idx="3">
-                <c:v>58</c:v>
-              </c:pt>
-              <c:pt idx="4">
-                <c:v>68</c:v>
-              </c:pt>
-            </c:numLit>
-          </c:val>
-        </c:ser>
-        <c:ser>
-          <c:idx val="1"/>
-          <c:order val="1"/>
-          <c:tx>
-            <c:v>Reference</c:v>
-          </c:tx>
-          <c:spPr>
-            <a:solidFill>
-              <a:srgbClr val="8C9B9D"/>
-            </a:solidFill>
-          </c:spPr>
-          <c:cat>
-            <c:strLit>
-              <c:ptCount val="5"/>
-              <c:pt idx="0">
-                <c:v>A</c:v>
-              </c:pt>
-              <c:pt idx="1">
-                <c:v>B</c:v>
-              </c:pt>
-              <c:pt idx="2">
-                <c:v>C</c:v>
-              </c:pt>
-              <c:pt idx="3">
-                <c:v>D</c:v>
-              </c:pt>
-              <c:pt idx="4">
-                <c:v>E</c:v>
-              </c:pt>
-            </c:strLit>
-          </c:cat>
-          <c:val>
-            <c:numLit>
-              <c:formatCode>General</c:formatCode>
-              <c:ptCount val="5"/>
-              <c:pt idx="0">
-                <c:v>32</c:v>
-              </c:pt>
-              <c:pt idx="1">
-                <c:v>36</c:v>
-              </c:pt>
-              <c:pt idx="2">
-                <c:v>40</c:v>
-              </c:pt>
-              <c:pt idx="3">
-                <c:v>44</c:v>
-              </c:pt>
-              <c:pt idx="4">
-                <c:v>49</c:v>
-              </c:pt>
-            </c:numLit>
-          </c:val>
-        </c:ser>
-        <c:axId val="1"/>
-        <c:axId val="2"/>
-      </c:lineChart>
-      <c:catAx>
-        <c:axId val="1"/>
-        <c:scaling>
-          <c:orientation val="minMax"/>
-        </c:scaling>
-        <c:axPos val="b"/>
-        <c:crossAx val="2"/>
-      </c:catAx>
-      <c:valAx>
-        <c:axId val="2"/>
-        <c:scaling>
-          <c:orientation val="minMax"/>
-        </c:scaling>
-        <c:axPos val="l"/>
-        <c:crossAx val="1"/>
-      </c:valAx>
-    </c:plotArea>
-    <c:plotVisOnly val="1"/>
-  </c:chart>
-</c:chartSpace>
-</file>
-
 <file path=ppt/slides/slide1.xml><?xml version="1.0" encoding="utf-8"?>
 <p:sld xmlns:p="http://schemas.openxmlformats.org/presentationml/2006/main">
   <p:cSld name="Opening claim">
+    <p:bg>
+      <p:bgPr>
+        <a:blipFill xmlns:a="http://schemas.openxmlformats.org/drawingml/2006/main">
+          <a:blip xmlns:r="http://schemas.openxmlformats.org/officeDocument/2006/relationships" r:embed="rIdOfficeKitImage33b8c33a8fc3d613_1"/>
+          <a:stretch>
+            <a:fillRect/>
+          </a:stretch>
+        </a:blipFill>
+      </p:bgPr>
+    </p:bg>
     <p:spTree>
       <p:nvGrpSpPr>
         <p:cNvPr id="1" name=""/>
@@ -520,38 +378,9 @@
           <a:chExt cx="0" cy="0"/>
         </a:xfrm>
       </p:grpSpPr>
-      <p:pic>
-        <p:nvPicPr>
-          <p:cNvPr id="2" name="cover-visual-field">
-            <a:extLst xmlns:a="http://schemas.openxmlformats.org/drawingml/2006/main">
-              <a:ext uri="{C183D7F6-B498-43B3-948B-1728B52AA6E4}">
-                <adec:decorative xmlns:adec="http://schemas.microsoft.com/office/drawing/2017/decorative" val="1"/>
-              </a:ext>
-            </a:extLst>
-          </p:cNvPr>
-          <p:cNvPicPr/>
-          <p:nvPr/>
-        </p:nvPicPr>
-        <p:blipFill>
-          <a:blip xmlns:r="http://schemas.openxmlformats.org/officeDocument/2006/relationships" xmlns:a="http://schemas.openxmlformats.org/drawingml/2006/main" r:embed="rIdOfficeKitImage13db13f70d7843cc_1"/>
-          <a:srcRect xmlns:a="http://schemas.openxmlformats.org/drawingml/2006/main" l="0" t="34180" r="0" b="34180"/>
-          <a:stretch xmlns:a="http://schemas.openxmlformats.org/drawingml/2006/main">
-            <a:fillRect/>
-          </a:stretch>
-        </p:blipFill>
-        <p:spPr>
-          <a:xfrm xmlns:a="http://schemas.openxmlformats.org/drawingml/2006/main" flipH="1">
-            <a:off x="0" y="0"/>
-            <a:ext cx="15240000" cy="8572500"/>
-          </a:xfrm>
-          <a:prstGeom xmlns:a="http://schemas.openxmlformats.org/drawingml/2006/main" prst="rect">
-            <a:avLst/>
-          </a:prstGeom>
-        </p:spPr>
-      </p:pic>
-      <p:sp>
-        <p:nvSpPr>
-          <p:cNvPr id="3" name="editorial-cover-scrim"/>
+      <p:sp>
+        <p:nvSpPr>
+          <p:cNvPr id="2" name="editorial-cover-scrim"/>
           <p:cNvSpPr/>
           <p:nvPr/>
         </p:nvSpPr>
@@ -589,7 +418,7 @@
       </p:sp>
       <p:sp>
         <p:nvSpPr>
-          <p:cNvPr id="4" name="eyebrow"/>
+          <p:cNvPr id="3" name="eyebrow"/>
           <p:cNvSpPr txBox="1"/>
           <p:nvPr/>
         </p:nvSpPr>
@@ -626,7 +455,7 @@
       </p:sp>
       <p:sp>
         <p:nvSpPr>
-          <p:cNvPr id="5" name="cover-title"/>
+          <p:cNvPr id="4" name="cover-title"/>
           <p:cNvSpPr txBox="1"/>
           <p:nvPr/>
         </p:nvSpPr>
@@ -663,7 +492,7 @@
       </p:sp>
       <p:sp>
         <p:nvSpPr>
-          <p:cNvPr id="6" name="cover-subtitle"/>
+          <p:cNvPr id="5" name="cover-subtitle"/>
           <p:cNvSpPr txBox="1"/>
           <p:nvPr/>
         </p:nvSpPr>
@@ -700,7 +529,7 @@
       </p:sp>
       <p:sp>
         <p:nvSpPr>
-          <p:cNvPr id="7" name="cover-photo-rule"/>
+          <p:cNvPr id="6" name="cover-photo-rule"/>
           <p:cNvSpPr/>
           <p:nvPr/>
         </p:nvSpPr>
@@ -734,7 +563,7 @@
       </p:sp>
       <p:sp>
         <p:nvSpPr>
-          <p:cNvPr id="8" name="cover-thesis"/>
+          <p:cNvPr id="7" name="cover-thesis"/>
           <p:cNvSpPr txBox="1"/>
           <p:nvPr/>
         </p:nvSpPr>
@@ -771,7 +600,7 @@
       </p:sp>
       <p:sp>
         <p:nvSpPr>
-          <p:cNvPr id="9" name="cover-source"/>
+          <p:cNvPr id="8" name="cover-source"/>
           <p:cNvSpPr txBox="1"/>
           <p:nvPr/>
         </p:nvSpPr>
@@ -808,7 +637,7 @@
       </p:sp>
       <p:sp>
         <p:nvSpPr>
-          <p:cNvPr id="10" name="page-number"/>
+          <p:cNvPr id="9" name="page-number"/>
           <p:cNvSpPr txBox="1"/>
           <p:nvPr/>
         </p:nvSpPr>
@@ -855,6 +684,16 @@
 <file path=ppt/slides/slide2.xml><?xml version="1.0" encoding="utf-8"?>
 <p:sld xmlns:p="http://schemas.openxmlformats.org/presentationml/2006/main">
   <p:cSld name="Argument">
+    <p:bg>
+      <p:bgPr>
+        <a:blipFill xmlns:a="http://schemas.openxmlformats.org/drawingml/2006/main">
+          <a:blip xmlns:r="http://schemas.openxmlformats.org/officeDocument/2006/relationships" r:embed="rIdOfficeKitImage31956823b229fb66_1"/>
+          <a:stretch>
+            <a:fillRect/>
+          </a:stretch>
+        </a:blipFill>
+      </p:bgPr>
+    </p:bg>
     <p:spTree>
       <p:nvGrpSpPr>
         <p:cNvPr id="1" name=""/>
@@ -871,20 +710,22 @@
       </p:grpSpPr>
       <p:sp>
         <p:nvSpPr>
-          <p:cNvPr id="2" name="background"/>
+          <p:cNvPr id="2" name="argument-paper-scrim"/>
           <p:cNvSpPr/>
           <p:nvPr/>
         </p:nvSpPr>
         <p:spPr>
           <a:xfrm xmlns:a="http://schemas.openxmlformats.org/drawingml/2006/main">
             <a:off x="0" y="0"/>
-            <a:ext cx="15240000" cy="8572500"/>
+            <a:ext cx="8191500" cy="8572500"/>
           </a:xfrm>
           <a:prstGeom xmlns:a="http://schemas.openxmlformats.org/drawingml/2006/main" prst="rect">
             <a:avLst/>
           </a:prstGeom>
           <a:solidFill xmlns:a="http://schemas.openxmlformats.org/drawingml/2006/main">
-            <a:srgbClr val="F3EFE4"/>
+            <a:srgbClr val="F3EFE4">
+              <a:alpha val="96000"/>
+            </a:srgbClr>
           </a:solidFill>
           <a:ln xmlns:a="http://schemas.openxmlformats.org/drawingml/2006/main" w="0">
             <a:solidFill>
@@ -985,29 +826,42 @@
         <p:spPr>
           <a:xfrm xmlns:a="http://schemas.openxmlformats.org/drawingml/2006/main">
             <a:off x="914400" y="1314450"/>
-            <a:ext cx="11811000" cy="552450"/>
-          </a:xfrm>
-          <a:prstGeom xmlns:a="http://schemas.openxmlformats.org/drawingml/2006/main" prst="rect">
-            <a:avLst/>
-          </a:prstGeom>
-          <a:noFill xmlns:a="http://schemas.openxmlformats.org/drawingml/2006/main"/>
-          <a:ln xmlns:a="http://schemas.openxmlformats.org/drawingml/2006/main" w="0">
-            <a:noFill/>
-          </a:ln>
-        </p:spPr>
-        <p:txBody>
-          <a:bodyPr xmlns:a="http://schemas.openxmlformats.org/drawingml/2006/main" wrap="square" lIns="0" tIns="0" rIns="0" bIns="0" anchor="t"/>
-          <a:lstStyle xmlns:a="http://schemas.openxmlformats.org/drawingml/2006/main"/>
-          <a:p xmlns:a="http://schemas.openxmlformats.org/drawingml/2006/main">
-            <a:r>
-              <a:rPr lang="en-US" sz="2850" b="1">
+            <a:ext cx="6286500" cy="914400"/>
+          </a:xfrm>
+          <a:prstGeom xmlns:a="http://schemas.openxmlformats.org/drawingml/2006/main" prst="rect">
+            <a:avLst/>
+          </a:prstGeom>
+          <a:noFill xmlns:a="http://schemas.openxmlformats.org/drawingml/2006/main"/>
+          <a:ln xmlns:a="http://schemas.openxmlformats.org/drawingml/2006/main" w="0">
+            <a:noFill/>
+          </a:ln>
+        </p:spPr>
+        <p:txBody>
+          <a:bodyPr xmlns:a="http://schemas.openxmlformats.org/drawingml/2006/main" wrap="square" lIns="0" tIns="0" rIns="0" bIns="0" anchor="t"/>
+          <a:lstStyle xmlns:a="http://schemas.openxmlformats.org/drawingml/2006/main"/>
+          <a:p xmlns:a="http://schemas.openxmlformats.org/drawingml/2006/main">
+            <a:r>
+              <a:rPr lang="en-US" sz="2550" b="1">
                 <a:solidFill>
                   <a:srgbClr val="1D4150"/>
                 </a:solidFill>
                 <a:latin typeface="Arial"/>
                 <a:ea typeface="Arial"/>
               </a:rPr>
-              <a:t>The proposition is the page's visual center</a:t>
+              <a:t>The proposition is the page's visual</a:t>
+            </a:r>
+            <a:endParaRPr lang="en-US"/>
+          </a:p>
+          <a:p xmlns:a="http://schemas.openxmlformats.org/drawingml/2006/main">
+            <a:r>
+              <a:rPr lang="en-US" sz="2550" b="1">
+                <a:solidFill>
+                  <a:srgbClr val="1D4150"/>
+                </a:solidFill>
+                <a:latin typeface="Arial"/>
+                <a:ea typeface="Arial"/>
+              </a:rPr>
+              <a:t>center</a:t>
             </a:r>
             <a:endParaRPr lang="en-US"/>
           </a:p>
@@ -1021,8 +875,8 @@
         </p:nvSpPr>
         <p:spPr>
           <a:xfrm xmlns:a="http://schemas.openxmlformats.org/drawingml/2006/main">
-            <a:off x="952500" y="1981200"/>
-            <a:ext cx="10477500" cy="266700"/>
+            <a:off x="952500" y="2190750"/>
+            <a:ext cx="6096000" cy="266700"/>
           </a:xfrm>
           <a:prstGeom xmlns:a="http://schemas.openxmlformats.org/drawingml/2006/main" prst="rect">
             <a:avLst/>
@@ -1208,8 +1062,8 @@
           <p:nvPr/>
         </p:nvPicPr>
         <p:blipFill>
-          <a:blip xmlns:r="http://schemas.openxmlformats.org/officeDocument/2006/relationships" xmlns:a="http://schemas.openxmlformats.org/drawingml/2006/main" r:embed="rIdOfficeKitImage7790b68b5d8fcd92_1"/>
-          <a:srcRect xmlns:a="http://schemas.openxmlformats.org/drawingml/2006/main" l="0" t="31920" r="0" b="31920"/>
+          <a:blip xmlns:r="http://schemas.openxmlformats.org/officeDocument/2006/relationships" xmlns:a="http://schemas.openxmlformats.org/drawingml/2006/main" r:embed="rIdOfficeKitImagec7b73f8fac405495_1"/>
+          <a:srcRect xmlns:a="http://schemas.openxmlformats.org/drawingml/2006/main" l="0" t="31910" r="0" b="31910"/>
           <a:stretch xmlns:a="http://schemas.openxmlformats.org/drawingml/2006/main">
             <a:fillRect/>
           </a:stretch>
@@ -1381,6 +1235,16 @@
 <file path=ppt/slides/slide3.xml><?xml version="1.0" encoding="utf-8"?>
 <p:sld xmlns:p="http://schemas.openxmlformats.org/presentationml/2006/main">
   <p:cSld name="Evidence">
+    <p:bg>
+      <p:bgPr>
+        <a:blipFill xmlns:a="http://schemas.openxmlformats.org/drawingml/2006/main">
+          <a:blip xmlns:r="http://schemas.openxmlformats.org/officeDocument/2006/relationships" r:embed="rIdOfficeKitImage59ee3aa5202fd02f_1"/>
+          <a:stretch>
+            <a:fillRect/>
+          </a:stretch>
+        </a:blipFill>
+      </p:bgPr>
+    </p:bg>
     <p:spTree>
       <p:nvGrpSpPr>
         <p:cNvPr id="1" name=""/>
@@ -1397,20 +1261,22 @@
       </p:grpSpPr>
       <p:sp>
         <p:nvSpPr>
-          <p:cNvPr id="2" name="background"/>
+          <p:cNvPr id="2" name="evidence-paper-scrim"/>
           <p:cNvSpPr/>
           <p:nvPr/>
         </p:nvSpPr>
         <p:spPr>
           <a:xfrm xmlns:a="http://schemas.openxmlformats.org/drawingml/2006/main">
             <a:off x="0" y="0"/>
-            <a:ext cx="15240000" cy="8572500"/>
+            <a:ext cx="8191500" cy="8572500"/>
           </a:xfrm>
           <a:prstGeom xmlns:a="http://schemas.openxmlformats.org/drawingml/2006/main" prst="rect">
             <a:avLst/>
           </a:prstGeom>
           <a:solidFill xmlns:a="http://schemas.openxmlformats.org/drawingml/2006/main">
-            <a:srgbClr val="F3EFE4"/>
+            <a:srgbClr val="F3EFE4">
+              <a:alpha val="96000"/>
+            </a:srgbClr>
           </a:solidFill>
           <a:ln xmlns:a="http://schemas.openxmlformats.org/drawingml/2006/main" w="0">
             <a:solidFill>
@@ -1511,29 +1377,42 @@
         <p:spPr>
           <a:xfrm xmlns:a="http://schemas.openxmlformats.org/drawingml/2006/main">
             <a:off x="914400" y="1314450"/>
-            <a:ext cx="11811000" cy="552450"/>
-          </a:xfrm>
-          <a:prstGeom xmlns:a="http://schemas.openxmlformats.org/drawingml/2006/main" prst="rect">
-            <a:avLst/>
-          </a:prstGeom>
-          <a:noFill xmlns:a="http://schemas.openxmlformats.org/drawingml/2006/main"/>
-          <a:ln xmlns:a="http://schemas.openxmlformats.org/drawingml/2006/main" w="0">
-            <a:noFill/>
-          </a:ln>
-        </p:spPr>
-        <p:txBody>
-          <a:bodyPr xmlns:a="http://schemas.openxmlformats.org/drawingml/2006/main" wrap="square" lIns="0" tIns="0" rIns="0" bIns="0" anchor="t"/>
-          <a:lstStyle xmlns:a="http://schemas.openxmlformats.org/drawingml/2006/main"/>
-          <a:p xmlns:a="http://schemas.openxmlformats.org/drawingml/2006/main">
-            <a:r>
-              <a:rPr lang="en-US" sz="2850" b="1">
+            <a:ext cx="6286500" cy="914400"/>
+          </a:xfrm>
+          <a:prstGeom xmlns:a="http://schemas.openxmlformats.org/drawingml/2006/main" prst="rect">
+            <a:avLst/>
+          </a:prstGeom>
+          <a:noFill xmlns:a="http://schemas.openxmlformats.org/drawingml/2006/main"/>
+          <a:ln xmlns:a="http://schemas.openxmlformats.org/drawingml/2006/main" w="0">
+            <a:noFill/>
+          </a:ln>
+        </p:spPr>
+        <p:txBody>
+          <a:bodyPr xmlns:a="http://schemas.openxmlformats.org/drawingml/2006/main" wrap="square" lIns="0" tIns="0" rIns="0" bIns="0" anchor="t"/>
+          <a:lstStyle xmlns:a="http://schemas.openxmlformats.org/drawingml/2006/main"/>
+          <a:p xmlns:a="http://schemas.openxmlformats.org/drawingml/2006/main">
+            <a:r>
+              <a:rPr lang="en-US" sz="2550" b="1">
                 <a:solidFill>
                   <a:srgbClr val="1D4150"/>
                 </a:solidFill>
                 <a:latin typeface="Arial"/>
                 <a:ea typeface="Arial"/>
               </a:rPr>
-              <a:t>The signal grows when the invitation stays measurable</a:t>
+              <a:t>The signal grows when the invitation</a:t>
+            </a:r>
+            <a:endParaRPr lang="en-US"/>
+          </a:p>
+          <a:p xmlns:a="http://schemas.openxmlformats.org/drawingml/2006/main">
+            <a:r>
+              <a:rPr lang="en-US" sz="2550" b="1">
+                <a:solidFill>
+                  <a:srgbClr val="1D4150"/>
+                </a:solidFill>
+                <a:latin typeface="Arial"/>
+                <a:ea typeface="Arial"/>
+              </a:rPr>
+              <a:t>stays measurable</a:t>
             </a:r>
             <a:endParaRPr lang="en-US"/>
           </a:p>
@@ -1547,8 +1426,8 @@
         </p:nvSpPr>
         <p:spPr>
           <a:xfrm xmlns:a="http://schemas.openxmlformats.org/drawingml/2006/main">
-            <a:off x="952500" y="1981200"/>
-            <a:ext cx="10477500" cy="266700"/>
+            <a:off x="952500" y="2190750"/>
+            <a:ext cx="6096000" cy="266700"/>
           </a:xfrm>
           <a:prstGeom xmlns:a="http://schemas.openxmlformats.org/drawingml/2006/main" prst="rect">
             <a:avLst/>
@@ -1624,7 +1503,7 @@
         </p:xfrm>
         <a:graphic xmlns:a="http://schemas.openxmlformats.org/drawingml/2006/main">
           <a:graphicData uri="http://schemas.openxmlformats.org/drawingml/2006/chart">
-            <c:chart xmlns:r="http://schemas.openxmlformats.org/officeDocument/2006/relationships" xmlns:c="http://schemas.openxmlformats.org/drawingml/2006/chart" r:id="Rdfd2b255d58543ec"/>
+            <c:chart xmlns:r="http://schemas.openxmlformats.org/officeDocument/2006/relationships" xmlns:c="http://schemas.openxmlformats.org/drawingml/2006/chart" r:id="Rd6074b17c6ca4791"/>
           </a:graphicData>
         </a:graphic>
       </p:graphicFrame>
@@ -1760,14 +1639,40 @@
           <a:lstStyle xmlns:a="http://schemas.openxmlformats.org/drawingml/2006/main"/>
           <a:p xmlns:a="http://schemas.openxmlformats.org/drawingml/2006/main">
             <a:r>
-              <a:rPr lang="en-US" sz="1650" b="1">
+              <a:rPr lang="en-US" sz="1350" b="1">
                 <a:solidFill>
                   <a:srgbClr val="1D4150"/>
                 </a:solidFill>
                 <a:latin typeface="Arial"/>
                 <a:ea typeface="Arial"/>
               </a:rPr>
-              <a:t>Reach is useful only when the audience can see and take the next step.</a:t>
+              <a:t>Reach is useful only when the</a:t>
+            </a:r>
+            <a:endParaRPr lang="en-US"/>
+          </a:p>
+          <a:p xmlns:a="http://schemas.openxmlformats.org/drawingml/2006/main">
+            <a:r>
+              <a:rPr lang="en-US" sz="1350" b="1">
+                <a:solidFill>
+                  <a:srgbClr val="1D4150"/>
+                </a:solidFill>
+                <a:latin typeface="Arial"/>
+                <a:ea typeface="Arial"/>
+              </a:rPr>
+              <a:t>audience can see and take the</a:t>
+            </a:r>
+            <a:endParaRPr lang="en-US"/>
+          </a:p>
+          <a:p xmlns:a="http://schemas.openxmlformats.org/drawingml/2006/main">
+            <a:r>
+              <a:rPr lang="en-US" sz="1350" b="1">
+                <a:solidFill>
+                  <a:srgbClr val="1D4150"/>
+                </a:solidFill>
+                <a:latin typeface="Arial"/>
+                <a:ea typeface="Arial"/>
+              </a:rPr>
+              <a:t>next step.</a:t>
             </a:r>
             <a:endParaRPr lang="en-US"/>
           </a:p>
@@ -2062,22 +1967,22 @@
         <p:spPr>
           <a:xfrm xmlns:a="http://schemas.openxmlformats.org/drawingml/2006/main">
             <a:off x="914400" y="1314450"/>
-            <a:ext cx="11811000" cy="552450"/>
-          </a:xfrm>
-          <a:prstGeom xmlns:a="http://schemas.openxmlformats.org/drawingml/2006/main" prst="rect">
-            <a:avLst/>
-          </a:prstGeom>
-          <a:noFill xmlns:a="http://schemas.openxmlformats.org/drawingml/2006/main"/>
-          <a:ln xmlns:a="http://schemas.openxmlformats.org/drawingml/2006/main" w="0">
-            <a:noFill/>
-          </a:ln>
-        </p:spPr>
-        <p:txBody>
-          <a:bodyPr xmlns:a="http://schemas.openxmlformats.org/drawingml/2006/main" wrap="square" lIns="0" tIns="0" rIns="0" bIns="0" anchor="t"/>
-          <a:lstStyle xmlns:a="http://schemas.openxmlformats.org/drawingml/2006/main"/>
-          <a:p xmlns:a="http://schemas.openxmlformats.org/drawingml/2006/main">
-            <a:r>
-              <a:rPr lang="en-US" sz="2850" b="1">
+            <a:ext cx="6286500" cy="552450"/>
+          </a:xfrm>
+          <a:prstGeom xmlns:a="http://schemas.openxmlformats.org/drawingml/2006/main" prst="rect">
+            <a:avLst/>
+          </a:prstGeom>
+          <a:noFill xmlns:a="http://schemas.openxmlformats.org/drawingml/2006/main"/>
+          <a:ln xmlns:a="http://schemas.openxmlformats.org/drawingml/2006/main" w="0">
+            <a:noFill/>
+          </a:ln>
+        </p:spPr>
+        <p:txBody>
+          <a:bodyPr xmlns:a="http://schemas.openxmlformats.org/drawingml/2006/main" wrap="square" lIns="0" tIns="0" rIns="0" bIns="0" anchor="t"/>
+          <a:lstStyle xmlns:a="http://schemas.openxmlformats.org/drawingml/2006/main"/>
+          <a:p xmlns:a="http://schemas.openxmlformats.org/drawingml/2006/main">
+            <a:r>
+              <a:rPr lang="en-US" sz="2550" b="1">
                 <a:solidFill>
                   <a:srgbClr val="1D4150"/>
                 </a:solidFill>
@@ -2099,7 +2004,7 @@
         <p:spPr>
           <a:xfrm xmlns:a="http://schemas.openxmlformats.org/drawingml/2006/main">
             <a:off x="952500" y="1981200"/>
-            <a:ext cx="10477500" cy="266700"/>
+            <a:ext cx="6096000" cy="266700"/>
           </a:xfrm>
           <a:prstGeom xmlns:a="http://schemas.openxmlformats.org/drawingml/2006/main" prst="rect">
             <a:avLst/>
@@ -2174,8 +2079,8 @@
           <p:nvPr/>
         </p:nvPicPr>
         <p:blipFill>
-          <a:blip xmlns:r="http://schemas.openxmlformats.org/officeDocument/2006/relationships" xmlns:a="http://schemas.openxmlformats.org/drawingml/2006/main" r:embed="rIdOfficeKitImagec7b73f8fac405495_1"/>
-          <a:srcRect xmlns:a="http://schemas.openxmlformats.org/drawingml/2006/main" l="0" t="28354" r="0" b="28354"/>
+          <a:blip xmlns:r="http://schemas.openxmlformats.org/officeDocument/2006/relationships" xmlns:a="http://schemas.openxmlformats.org/drawingml/2006/main" r:embed="rIdOfficeKitImageaeb6f74d36d260d0_1"/>
+          <a:srcRect xmlns:a="http://schemas.openxmlformats.org/drawingml/2006/main" l="0" t="31971" r="0" b="31971"/>
           <a:stretch xmlns:a="http://schemas.openxmlformats.org/drawingml/2006/main">
             <a:fillRect/>
           </a:stretch>
@@ -2183,7 +2088,7 @@
         <p:spPr>
           <a:xfrm xmlns:a="http://schemas.openxmlformats.org/drawingml/2006/main">
             <a:off x="990600" y="3162300"/>
-            <a:ext cx="3714750" cy="2857500"/>
+            <a:ext cx="3714750" cy="2381250"/>
           </a:xfrm>
           <a:prstGeom xmlns:a="http://schemas.openxmlformats.org/drawingml/2006/main" prst="rect">
             <a:avLst/>
@@ -2203,16 +2108,16 @@
           <p:nvPr/>
         </p:nvPicPr>
         <p:blipFill>
-          <a:blip xmlns:r="http://schemas.openxmlformats.org/officeDocument/2006/relationships" xmlns:a="http://schemas.openxmlformats.org/drawingml/2006/main" r:embed="rIdOfficeKitImage59ee3aa5202fd02f_1"/>
-          <a:srcRect xmlns:a="http://schemas.openxmlformats.org/drawingml/2006/main" l="0" t="39904" r="0" b="39904"/>
+          <a:blip xmlns:r="http://schemas.openxmlformats.org/officeDocument/2006/relationships" xmlns:a="http://schemas.openxmlformats.org/drawingml/2006/main" r:embed="rIdOfficeKitImage13db13f70d7843cc_1"/>
+          <a:srcRect xmlns:a="http://schemas.openxmlformats.org/drawingml/2006/main" l="0" t="32347" r="0" b="32347"/>
           <a:stretch xmlns:a="http://schemas.openxmlformats.org/drawingml/2006/main">
             <a:fillRect/>
           </a:stretch>
         </p:blipFill>
         <p:spPr>
-          <a:xfrm xmlns:a="http://schemas.openxmlformats.org/drawingml/2006/main">
+          <a:xfrm xmlns:a="http://schemas.openxmlformats.org/drawingml/2006/main" flipH="1">
             <a:off x="4895850" y="3162300"/>
-            <a:ext cx="3714750" cy="1333500"/>
+            <a:ext cx="1790700" cy="1123950"/>
           </a:xfrm>
           <a:prstGeom xmlns:a="http://schemas.openxmlformats.org/drawingml/2006/main" prst="rect">
             <a:avLst/>
@@ -2232,25 +2137,83 @@
           <p:nvPr/>
         </p:nvPicPr>
         <p:blipFill>
-          <a:blip xmlns:r="http://schemas.openxmlformats.org/officeDocument/2006/relationships" xmlns:a="http://schemas.openxmlformats.org/drawingml/2006/main" r:embed="rIdOfficeKitImageaeb6f74d36d260d0_1"/>
-          <a:srcRect xmlns:a="http://schemas.openxmlformats.org/drawingml/2006/main" l="0" t="39904" r="0" b="39904"/>
+          <a:blip xmlns:r="http://schemas.openxmlformats.org/officeDocument/2006/relationships" xmlns:a="http://schemas.openxmlformats.org/drawingml/2006/main" r:embed="rIdOfficeKitImage7790b68b5d8fcd92_1"/>
+          <a:srcRect xmlns:a="http://schemas.openxmlformats.org/drawingml/2006/main" l="0" t="32347" r="0" b="32347"/>
           <a:stretch xmlns:a="http://schemas.openxmlformats.org/drawingml/2006/main">
             <a:fillRect/>
           </a:stretch>
         </p:blipFill>
         <p:spPr>
           <a:xfrm xmlns:a="http://schemas.openxmlformats.org/drawingml/2006/main">
-            <a:off x="4895850" y="4686300"/>
-            <a:ext cx="3714750" cy="1333500"/>
+            <a:off x="6858000" y="3162300"/>
+            <a:ext cx="1790700" cy="1123950"/>
           </a:xfrm>
           <a:prstGeom xmlns:a="http://schemas.openxmlformats.org/drawingml/2006/main" prst="rect">
             <a:avLst/>
           </a:prstGeom>
         </p:spPr>
       </p:pic>
-      <p:sp>
-        <p:nvSpPr>
-          <p:cNvPr id="11" name="image-matrix-label"/>
+      <p:pic>
+        <p:nvPicPr>
+          <p:cNvPr id="11" name="image-evidence-3">
+            <a:extLst xmlns:a="http://schemas.openxmlformats.org/drawingml/2006/main">
+              <a:ext uri="{C183D7F6-B498-43B3-948B-1728B52AA6E4}">
+                <adec:decorative xmlns:adec="http://schemas.microsoft.com/office/drawing/2017/decorative" val="1"/>
+              </a:ext>
+            </a:extLst>
+          </p:cNvPr>
+          <p:cNvPicPr/>
+          <p:nvPr/>
+        </p:nvPicPr>
+        <p:blipFill>
+          <a:blip xmlns:r="http://schemas.openxmlformats.org/officeDocument/2006/relationships" xmlns:a="http://schemas.openxmlformats.org/drawingml/2006/main" r:embed="rIdOfficeKitImagec237998db8bee20d_1"/>
+          <a:srcRect xmlns:a="http://schemas.openxmlformats.org/drawingml/2006/main" l="0" t="32336" r="0" b="32336"/>
+          <a:stretch xmlns:a="http://schemas.openxmlformats.org/drawingml/2006/main">
+            <a:fillRect/>
+          </a:stretch>
+        </p:blipFill>
+        <p:spPr>
+          <a:xfrm xmlns:a="http://schemas.openxmlformats.org/drawingml/2006/main">
+            <a:off x="4895850" y="4457700"/>
+            <a:ext cx="1790700" cy="1123950"/>
+          </a:xfrm>
+          <a:prstGeom xmlns:a="http://schemas.openxmlformats.org/drawingml/2006/main" prst="rect">
+            <a:avLst/>
+          </a:prstGeom>
+        </p:spPr>
+      </p:pic>
+      <p:pic>
+        <p:nvPicPr>
+          <p:cNvPr id="12" name="image-evidence-4">
+            <a:extLst xmlns:a="http://schemas.openxmlformats.org/drawingml/2006/main">
+              <a:ext uri="{C183D7F6-B498-43B3-948B-1728B52AA6E4}">
+                <adec:decorative xmlns:adec="http://schemas.microsoft.com/office/drawing/2017/decorative" val="1"/>
+              </a:ext>
+            </a:extLst>
+          </p:cNvPr>
+          <p:cNvPicPr/>
+          <p:nvPr/>
+        </p:nvPicPr>
+        <p:blipFill>
+          <a:blip xmlns:r="http://schemas.openxmlformats.org/officeDocument/2006/relationships" xmlns:a="http://schemas.openxmlformats.org/drawingml/2006/main" r:embed="rIdOfficeKitImaged71bfa074cda59bb_1"/>
+          <a:srcRect xmlns:a="http://schemas.openxmlformats.org/drawingml/2006/main" l="0" t="32347" r="0" b="32347"/>
+          <a:stretch xmlns:a="http://schemas.openxmlformats.org/drawingml/2006/main">
+            <a:fillRect/>
+          </a:stretch>
+        </p:blipFill>
+        <p:spPr>
+          <a:xfrm xmlns:a="http://schemas.openxmlformats.org/drawingml/2006/main">
+            <a:off x="6858000" y="4457700"/>
+            <a:ext cx="1790700" cy="1123950"/>
+          </a:xfrm>
+          <a:prstGeom xmlns:a="http://schemas.openxmlformats.org/drawingml/2006/main" prst="rect">
+            <a:avLst/>
+          </a:prstGeom>
+        </p:spPr>
+      </p:pic>
+      <p:sp>
+        <p:nvSpPr>
+          <p:cNvPr id="13" name="image-matrix-label"/>
           <p:cNvSpPr txBox="1"/>
           <p:nvPr/>
         </p:nvSpPr>
@@ -2287,7 +2250,7 @@
       </p:sp>
       <p:sp>
         <p:nvSpPr>
-          <p:cNvPr id="12" name="image-matrix-title"/>
+          <p:cNvPr id="14" name="image-matrix-title"/>
           <p:cNvSpPr txBox="1"/>
           <p:nvPr/>
         </p:nvSpPr>
@@ -2316,52 +2279,78 @@
                 <a:latin typeface="Arial"/>
                 <a:ea typeface="Arial"/>
               </a:rPr>
-              <a:t>One subject, three ways to notice it.</a:t>
-            </a:r>
-            <a:endParaRPr lang="en-US"/>
-          </a:p>
-        </p:txBody>
-      </p:sp>
-      <p:sp>
-        <p:nvSpPr>
-          <p:cNvPr id="13" name="image-matrix-body"/>
+              <a:t>One subject, five ways to notice it.</a:t>
+            </a:r>
+            <a:endParaRPr lang="en-US"/>
+          </a:p>
+        </p:txBody>
+      </p:sp>
+      <p:sp>
+        <p:nvSpPr>
+          <p:cNvPr id="15" name="image-matrix-body"/>
           <p:cNvSpPr txBox="1"/>
           <p:nvPr/>
         </p:nvSpPr>
         <p:spPr>
           <a:xfrm xmlns:a="http://schemas.openxmlformats.org/drawingml/2006/main">
             <a:off x="9620250" y="4953000"/>
-            <a:ext cx="3524250" cy="666750"/>
-          </a:xfrm>
-          <a:prstGeom xmlns:a="http://schemas.openxmlformats.org/drawingml/2006/main" prst="rect">
-            <a:avLst/>
-          </a:prstGeom>
-          <a:noFill xmlns:a="http://schemas.openxmlformats.org/drawingml/2006/main"/>
-          <a:ln xmlns:a="http://schemas.openxmlformats.org/drawingml/2006/main" w="0">
-            <a:noFill/>
-          </a:ln>
-        </p:spPr>
-        <p:txBody>
-          <a:bodyPr xmlns:a="http://schemas.openxmlformats.org/drawingml/2006/main" wrap="square" lIns="0" tIns="0" rIns="0" bIns="0" anchor="t"/>
-          <a:lstStyle xmlns:a="http://schemas.openxmlformats.org/drawingml/2006/main"/>
-          <a:p xmlns:a="http://schemas.openxmlformats.org/drawingml/2006/main">
-            <a:r>
-              <a:rPr lang="en-US" sz="1275">
+            <a:ext cx="3524250" cy="781050"/>
+          </a:xfrm>
+          <a:prstGeom xmlns:a="http://schemas.openxmlformats.org/drawingml/2006/main" prst="rect">
+            <a:avLst/>
+          </a:prstGeom>
+          <a:noFill xmlns:a="http://schemas.openxmlformats.org/drawingml/2006/main"/>
+          <a:ln xmlns:a="http://schemas.openxmlformats.org/drawingml/2006/main" w="0">
+            <a:noFill/>
+          </a:ln>
+        </p:spPr>
+        <p:txBody>
+          <a:bodyPr xmlns:a="http://schemas.openxmlformats.org/drawingml/2006/main" wrap="square" lIns="0" tIns="0" rIns="0" bIns="0" anchor="t"/>
+          <a:lstStyle xmlns:a="http://schemas.openxmlformats.org/drawingml/2006/main"/>
+          <a:p xmlns:a="http://schemas.openxmlformats.org/drawingml/2006/main">
+            <a:r>
+              <a:rPr lang="en-US" sz="1200">
                 <a:solidFill>
                   <a:srgbClr val="8C9B9D"/>
                 </a:solidFill>
                 <a:latin typeface="Arial"/>
                 <a:ea typeface="Arial"/>
               </a:rPr>
-              <a:t>Use unequal frames to show facets of one idea. The crop carries the mood; the label carries the claim.</a:t>
-            </a:r>
-            <a:endParaRPr lang="en-US"/>
-          </a:p>
-        </p:txBody>
-      </p:sp>
-      <p:sp>
-        <p:nvSpPr>
-          <p:cNvPr id="14" name="source"/>
+              <a:t>One dominant frame plus four</a:t>
+            </a:r>
+            <a:endParaRPr lang="en-US"/>
+          </a:p>
+          <a:p xmlns:a="http://schemas.openxmlformats.org/drawingml/2006/main">
+            <a:r>
+              <a:rPr lang="en-US" sz="1200">
+                <a:solidFill>
+                  <a:srgbClr val="8C9B9D"/>
+                </a:solidFill>
+                <a:latin typeface="Arial"/>
+                <a:ea typeface="Arial"/>
+              </a:rPr>
+              <a:t>supporting crops. Image carries</a:t>
+            </a:r>
+            <a:endParaRPr lang="en-US"/>
+          </a:p>
+          <a:p xmlns:a="http://schemas.openxmlformats.org/drawingml/2006/main">
+            <a:r>
+              <a:rPr lang="en-US" sz="1200">
+                <a:solidFill>
+                  <a:srgbClr val="8C9B9D"/>
+                </a:solidFill>
+                <a:latin typeface="Arial"/>
+                <a:ea typeface="Arial"/>
+              </a:rPr>
+              <a:t>mood; labels carry the claim.</a:t>
+            </a:r>
+            <a:endParaRPr lang="en-US"/>
+          </a:p>
+        </p:txBody>
+      </p:sp>
+      <p:sp>
+        <p:nvSpPr>
+          <p:cNvPr id="16" name="source"/>
           <p:cNvSpPr txBox="1"/>
           <p:nvPr/>
         </p:nvSpPr>
@@ -2398,7 +2387,7 @@
       </p:sp>
       <p:sp>
         <p:nvSpPr>
-          <p:cNvPr id="15" name="page-number"/>
+          <p:cNvPr id="17" name="page-number"/>
           <p:cNvSpPr txBox="1"/>
           <p:nvPr/>
         </p:nvSpPr>
@@ -2445,6 +2434,16 @@
 <file path=ppt/slides/slide5.xml><?xml version="1.0" encoding="utf-8"?>
 <p:sld xmlns:p="http://schemas.openxmlformats.org/presentationml/2006/main">
   <p:cSld name="Visual carrier">
+    <p:bg>
+      <p:bgPr>
+        <a:blipFill xmlns:a="http://schemas.openxmlformats.org/drawingml/2006/main">
+          <a:blip xmlns:r="http://schemas.openxmlformats.org/officeDocument/2006/relationships" r:embed="rIdOfficeKitImage8fbc298f8d1b7a3c_1"/>
+          <a:stretch>
+            <a:fillRect/>
+          </a:stretch>
+        </a:blipFill>
+      </p:bgPr>
+    </p:bg>
     <p:spTree>
       <p:nvGrpSpPr>
         <p:cNvPr id="1" name=""/>
@@ -2461,20 +2460,22 @@
       </p:grpSpPr>
       <p:sp>
         <p:nvSpPr>
-          <p:cNvPr id="2" name="background"/>
+          <p:cNvPr id="2" name="visual-scrim"/>
           <p:cNvSpPr/>
           <p:nvPr/>
         </p:nvSpPr>
         <p:spPr>
           <a:xfrm xmlns:a="http://schemas.openxmlformats.org/drawingml/2006/main">
             <a:off x="0" y="0"/>
-            <a:ext cx="15240000" cy="8572500"/>
+            <a:ext cx="6858000" cy="8572500"/>
           </a:xfrm>
           <a:prstGeom xmlns:a="http://schemas.openxmlformats.org/drawingml/2006/main" prst="rect">
             <a:avLst/>
           </a:prstGeom>
           <a:solidFill xmlns:a="http://schemas.openxmlformats.org/drawingml/2006/main">
-            <a:srgbClr val="F3EFE4"/>
+            <a:srgbClr val="F3EFE4">
+              <a:alpha val="88000"/>
+            </a:srgbClr>
           </a:solidFill>
           <a:ln xmlns:a="http://schemas.openxmlformats.org/drawingml/2006/main" w="0">
             <a:solidFill>
@@ -2497,14 +2498,125 @@
       </p:sp>
       <p:sp>
         <p:nvSpPr>
-          <p:cNvPr id="3" name="visual-top-rule"/>
+          <p:cNvPr id="3" name="visual-eyebrow"/>
+          <p:cNvSpPr txBox="1"/>
+          <p:nvPr/>
+        </p:nvSpPr>
+        <p:spPr>
+          <a:xfrm xmlns:a="http://schemas.openxmlformats.org/drawingml/2006/main">
+            <a:off x="914400" y="895350"/>
+            <a:ext cx="6667500" cy="228600"/>
+          </a:xfrm>
+          <a:prstGeom xmlns:a="http://schemas.openxmlformats.org/drawingml/2006/main" prst="rect">
+            <a:avLst/>
+          </a:prstGeom>
+          <a:noFill xmlns:a="http://schemas.openxmlformats.org/drawingml/2006/main"/>
+          <a:ln xmlns:a="http://schemas.openxmlformats.org/drawingml/2006/main" w="0">
+            <a:noFill/>
+          </a:ln>
+        </p:spPr>
+        <p:txBody>
+          <a:bodyPr xmlns:a="http://schemas.openxmlformats.org/drawingml/2006/main" wrap="square" lIns="0" tIns="0" rIns="0" bIns="0" anchor="t"/>
+          <a:lstStyle xmlns:a="http://schemas.openxmlformats.org/drawingml/2006/main"/>
+          <a:p xmlns:a="http://schemas.openxmlformats.org/drawingml/2006/main">
+            <a:r>
+              <a:rPr lang="en-US" sz="1200" b="1">
+                <a:solidFill>
+                  <a:srgbClr val="0B8EA3"/>
+                </a:solidFill>
+                <a:latin typeface="Arial"/>
+                <a:ea typeface="Arial"/>
+              </a:rPr>
+              <a:t>AQUA IMPACT STORY · VISUAL CARRIER</a:t>
+            </a:r>
+            <a:endParaRPr lang="en-US"/>
+          </a:p>
+        </p:txBody>
+      </p:sp>
+      <p:sp>
+        <p:nvSpPr>
+          <p:cNvPr id="4" name="visual-title"/>
+          <p:cNvSpPr txBox="1"/>
+          <p:nvPr/>
+        </p:nvSpPr>
+        <p:spPr>
+          <a:xfrm xmlns:a="http://schemas.openxmlformats.org/drawingml/2006/main">
+            <a:off x="914400" y="1638300"/>
+            <a:ext cx="5334000" cy="1143000"/>
+          </a:xfrm>
+          <a:prstGeom xmlns:a="http://schemas.openxmlformats.org/drawingml/2006/main" prst="rect">
+            <a:avLst/>
+          </a:prstGeom>
+          <a:noFill xmlns:a="http://schemas.openxmlformats.org/drawingml/2006/main"/>
+          <a:ln xmlns:a="http://schemas.openxmlformats.org/drawingml/2006/main" w="0">
+            <a:noFill/>
+          </a:ln>
+        </p:spPr>
+        <p:txBody>
+          <a:bodyPr xmlns:a="http://schemas.openxmlformats.org/drawingml/2006/main" wrap="square" lIns="0" tIns="0" rIns="0" bIns="0" anchor="t"/>
+          <a:lstStyle xmlns:a="http://schemas.openxmlformats.org/drawingml/2006/main"/>
+          <a:p xmlns:a="http://schemas.openxmlformats.org/drawingml/2006/main">
+            <a:r>
+              <a:rPr lang="en-US" sz="3300" b="1">
+                <a:solidFill>
+                  <a:srgbClr val="1D4150"/>
+                </a:solidFill>
+                <a:latin typeface="Arial"/>
+                <a:ea typeface="Arial"/>
+              </a:rPr>
+              <a:t>Let the subject do the work</a:t>
+            </a:r>
+            <a:endParaRPr lang="en-US"/>
+          </a:p>
+        </p:txBody>
+      </p:sp>
+      <p:sp>
+        <p:nvSpPr>
+          <p:cNvPr id="5" name="visual-body"/>
+          <p:cNvSpPr txBox="1"/>
+          <p:nvPr/>
+        </p:nvSpPr>
+        <p:spPr>
+          <a:xfrm xmlns:a="http://schemas.openxmlformats.org/drawingml/2006/main">
+            <a:off x="914400" y="3219450"/>
+            <a:ext cx="4762500" cy="685800"/>
+          </a:xfrm>
+          <a:prstGeom xmlns:a="http://schemas.openxmlformats.org/drawingml/2006/main" prst="rect">
+            <a:avLst/>
+          </a:prstGeom>
+          <a:noFill xmlns:a="http://schemas.openxmlformats.org/drawingml/2006/main"/>
+          <a:ln xmlns:a="http://schemas.openxmlformats.org/drawingml/2006/main" w="0">
+            <a:noFill/>
+          </a:ln>
+        </p:spPr>
+        <p:txBody>
+          <a:bodyPr xmlns:a="http://schemas.openxmlformats.org/drawingml/2006/main" wrap="square" lIns="0" tIns="0" rIns="0" bIns="0" anchor="t"/>
+          <a:lstStyle xmlns:a="http://schemas.openxmlformats.org/drawingml/2006/main"/>
+          <a:p xmlns:a="http://schemas.openxmlformats.org/drawingml/2006/main">
+            <a:r>
+              <a:rPr lang="en-US" sz="1800">
+                <a:solidFill>
+                  <a:srgbClr val="1D4150"/>
+                </a:solidFill>
+                <a:latin typeface="Arial"/>
+                <a:ea typeface="Arial"/>
+              </a:rPr>
+              <a:t>A strong crop gives the proposition a place to live.</a:t>
+            </a:r>
+            <a:endParaRPr lang="en-US"/>
+          </a:p>
+        </p:txBody>
+      </p:sp>
+      <p:sp>
+        <p:nvSpPr>
+          <p:cNvPr id="6" name="visual-rule"/>
           <p:cNvSpPr/>
           <p:nvPr/>
         </p:nvSpPr>
         <p:spPr>
           <a:xfrm xmlns:a="http://schemas.openxmlformats.org/drawingml/2006/main">
-            <a:off x="838200" y="666750"/>
-            <a:ext cx="13563600" cy="0"/>
+            <a:off x="914400" y="4476750"/>
+            <a:ext cx="4419600" cy="0"/>
           </a:xfrm>
           <a:prstGeom xmlns:a="http://schemas.openxmlformats.org/drawingml/2006/main" prst="line">
             <a:avLst/>
@@ -2531,14 +2643,14 @@
       </p:sp>
       <p:sp>
         <p:nvSpPr>
-          <p:cNvPr id="4" name="AQUA IMPACT STORY · VISUAL CARRIER"/>
-          <p:cNvSpPr txBox="1"/>
-          <p:nvPr/>
-        </p:nvSpPr>
-        <p:spPr>
-          <a:xfrm xmlns:a="http://schemas.openxmlformats.org/drawingml/2006/main">
-            <a:off x="914400" y="895350"/>
-            <a:ext cx="7239000" cy="228600"/>
+          <p:cNvPr id="7" name="visual-label"/>
+          <p:cNvSpPr txBox="1"/>
+          <p:nvPr/>
+        </p:nvSpPr>
+        <p:spPr>
+          <a:xfrm xmlns:a="http://schemas.openxmlformats.org/drawingml/2006/main">
+            <a:off x="914400" y="4819650"/>
+            <a:ext cx="4953000" cy="228600"/>
           </a:xfrm>
           <a:prstGeom xmlns:a="http://schemas.openxmlformats.org/drawingml/2006/main" prst="rect">
             <a:avLst/>
@@ -2560,288 +2672,15 @@
                 <a:latin typeface="Arial"/>
                 <a:ea typeface="Arial"/>
               </a:rPr>
-              <a:t>AQUA IMPACT STORY · VISUAL CARRIER</a:t>
-            </a:r>
-            <a:endParaRPr lang="en-US"/>
-          </a:p>
-        </p:txBody>
-      </p:sp>
-      <p:sp>
-        <p:nvSpPr>
-          <p:cNvPr id="5" name="visual-title"/>
-          <p:cNvSpPr txBox="1"/>
-          <p:nvPr/>
-        </p:nvSpPr>
-        <p:spPr>
-          <a:xfrm xmlns:a="http://schemas.openxmlformats.org/drawingml/2006/main">
-            <a:off x="914400" y="1314450"/>
-            <a:ext cx="11811000" cy="552450"/>
-          </a:xfrm>
-          <a:prstGeom xmlns:a="http://schemas.openxmlformats.org/drawingml/2006/main" prst="rect">
-            <a:avLst/>
-          </a:prstGeom>
-          <a:noFill xmlns:a="http://schemas.openxmlformats.org/drawingml/2006/main"/>
-          <a:ln xmlns:a="http://schemas.openxmlformats.org/drawingml/2006/main" w="0">
-            <a:noFill/>
-          </a:ln>
-        </p:spPr>
-        <p:txBody>
-          <a:bodyPr xmlns:a="http://schemas.openxmlformats.org/drawingml/2006/main" wrap="square" lIns="0" tIns="0" rIns="0" bIns="0" anchor="t"/>
-          <a:lstStyle xmlns:a="http://schemas.openxmlformats.org/drawingml/2006/main"/>
-          <a:p xmlns:a="http://schemas.openxmlformats.org/drawingml/2006/main">
-            <a:r>
-              <a:rPr lang="en-US" sz="2850" b="1">
-                <a:solidFill>
-                  <a:srgbClr val="1D4150"/>
-                </a:solidFill>
-                <a:latin typeface="Arial"/>
-                <a:ea typeface="Arial"/>
-              </a:rPr>
-              <a:t>Let the subject do the work</a:t>
-            </a:r>
-            <a:endParaRPr lang="en-US"/>
-          </a:p>
-        </p:txBody>
-      </p:sp>
-      <p:sp>
-        <p:nvSpPr>
-          <p:cNvPr id="6" name="visual-body"/>
-          <p:cNvSpPr txBox="1"/>
-          <p:nvPr/>
-        </p:nvSpPr>
-        <p:spPr>
-          <a:xfrm xmlns:a="http://schemas.openxmlformats.org/drawingml/2006/main">
-            <a:off x="952500" y="1981200"/>
-            <a:ext cx="10477500" cy="266700"/>
-          </a:xfrm>
-          <a:prstGeom xmlns:a="http://schemas.openxmlformats.org/drawingml/2006/main" prst="rect">
-            <a:avLst/>
-          </a:prstGeom>
-          <a:noFill xmlns:a="http://schemas.openxmlformats.org/drawingml/2006/main"/>
-          <a:ln xmlns:a="http://schemas.openxmlformats.org/drawingml/2006/main" w="0">
-            <a:noFill/>
-          </a:ln>
-        </p:spPr>
-        <p:txBody>
-          <a:bodyPr xmlns:a="http://schemas.openxmlformats.org/drawingml/2006/main" wrap="square" lIns="0" tIns="0" rIns="0" bIns="0" anchor="t"/>
-          <a:lstStyle xmlns:a="http://schemas.openxmlformats.org/drawingml/2006/main"/>
-          <a:p xmlns:a="http://schemas.openxmlformats.org/drawingml/2006/main">
-            <a:r>
-              <a:rPr lang="en-US" sz="1350">
-                <a:solidFill>
-                  <a:srgbClr val="8C9B9D"/>
-                </a:solidFill>
-                <a:latin typeface="Arial"/>
-                <a:ea typeface="Arial"/>
-              </a:rPr>
-              <a:t>A strong crop gives the proposition a place to live.</a:t>
-            </a:r>
-            <a:endParaRPr lang="en-US"/>
-          </a:p>
-        </p:txBody>
-      </p:sp>
-      <p:sp>
-        <p:nvSpPr>
-          <p:cNvPr id="7" name="visual-rule"/>
-          <p:cNvSpPr/>
-          <p:nvPr/>
-        </p:nvSpPr>
-        <p:spPr>
-          <a:xfrm xmlns:a="http://schemas.openxmlformats.org/drawingml/2006/main">
-            <a:off x="914400" y="2457450"/>
-            <a:ext cx="13411200" cy="0"/>
-          </a:xfrm>
-          <a:prstGeom xmlns:a="http://schemas.openxmlformats.org/drawingml/2006/main" prst="line">
-            <a:avLst/>
-          </a:prstGeom>
-          <a:noFill xmlns:a="http://schemas.openxmlformats.org/drawingml/2006/main"/>
-          <a:ln xmlns:a="http://schemas.openxmlformats.org/drawingml/2006/main" w="25400">
-            <a:solidFill>
-              <a:srgbClr val="8C9B9D"/>
-            </a:solidFill>
-            <a:prstDash val="solid"/>
-          </a:ln>
-        </p:spPr>
-        <p:txBody>
-          <a:bodyPr xmlns:a="http://schemas.openxmlformats.org/drawingml/2006/main" wrap="square" lIns="0" tIns="0" rIns="0" bIns="0" anchor="t"/>
-          <a:lstStyle xmlns:a="http://schemas.openxmlformats.org/drawingml/2006/main"/>
-          <a:p xmlns:a="http://schemas.openxmlformats.org/drawingml/2006/main">
-            <a:r>
-              <a:rPr lang="en-US"/>
-              <a:t/>
-            </a:r>
-            <a:endParaRPr lang="en-US"/>
-          </a:p>
-        </p:txBody>
-      </p:sp>
-      <p:graphicFrame>
-        <p:nvGraphicFramePr>
-          <p:cNvPr id="8" name="visual-field-chart"/>
-          <p:cNvGraphicFramePr>
-            <a:graphicFrameLocks xmlns:a="http://schemas.openxmlformats.org/drawingml/2006/main" noGrp="1"/>
-          </p:cNvGraphicFramePr>
-          <p:nvPr/>
-        </p:nvGraphicFramePr>
-        <p:xfrm>
-          <a:off xmlns:a="http://schemas.openxmlformats.org/drawingml/2006/main" x="914400" y="3028950"/>
-          <a:ext xmlns:a="http://schemas.openxmlformats.org/drawingml/2006/main" cx="7429500" cy="3695700"/>
-        </p:xfrm>
-        <a:graphic xmlns:a="http://schemas.openxmlformats.org/drawingml/2006/main">
-          <a:graphicData uri="http://schemas.openxmlformats.org/drawingml/2006/chart">
-            <c:chart xmlns:r="http://schemas.openxmlformats.org/officeDocument/2006/relationships" xmlns:c="http://schemas.openxmlformats.org/drawingml/2006/chart" r:id="R8943eb25121c44b1"/>
-          </a:graphicData>
-        </a:graphic>
-      </p:graphicFrame>
-      <p:sp>
-        <p:nvSpPr>
-          <p:cNvPr id="9" name="visual-note"/>
-          <p:cNvSpPr/>
-          <p:nvPr/>
-        </p:nvSpPr>
-        <p:spPr>
-          <a:xfrm xmlns:a="http://schemas.openxmlformats.org/drawingml/2006/main">
-            <a:off x="8858250" y="3333750"/>
-            <a:ext cx="4762500" cy="2381250"/>
-          </a:xfrm>
-          <a:prstGeom xmlns:a="http://schemas.openxmlformats.org/drawingml/2006/main" prst="rect">
-            <a:avLst/>
-          </a:prstGeom>
-          <a:solidFill xmlns:a="http://schemas.openxmlformats.org/drawingml/2006/main">
-            <a:srgbClr val="131A24"/>
-          </a:solidFill>
-          <a:ln xmlns:a="http://schemas.openxmlformats.org/drawingml/2006/main" w="12700">
-            <a:solidFill>
-              <a:srgbClr val="8C9B9D"/>
-            </a:solidFill>
-            <a:prstDash val="solid"/>
-          </a:ln>
-        </p:spPr>
-        <p:txBody>
-          <a:bodyPr xmlns:a="http://schemas.openxmlformats.org/drawingml/2006/main" wrap="square" lIns="0" tIns="0" rIns="0" bIns="0" anchor="t"/>
-          <a:lstStyle xmlns:a="http://schemas.openxmlformats.org/drawingml/2006/main"/>
-          <a:p xmlns:a="http://schemas.openxmlformats.org/drawingml/2006/main">
-            <a:r>
-              <a:rPr lang="en-US"/>
-              <a:t/>
-            </a:r>
-            <a:endParaRPr lang="en-US"/>
-          </a:p>
-        </p:txBody>
-      </p:sp>
-      <p:sp>
-        <p:nvSpPr>
-          <p:cNvPr id="10" name="visual-note-label"/>
-          <p:cNvSpPr txBox="1"/>
-          <p:nvPr/>
-        </p:nvSpPr>
-        <p:spPr>
-          <a:xfrm xmlns:a="http://schemas.openxmlformats.org/drawingml/2006/main">
-            <a:off x="9239250" y="3695700"/>
-            <a:ext cx="4000500" cy="228600"/>
-          </a:xfrm>
-          <a:prstGeom xmlns:a="http://schemas.openxmlformats.org/drawingml/2006/main" prst="rect">
-            <a:avLst/>
-          </a:prstGeom>
-          <a:noFill xmlns:a="http://schemas.openxmlformats.org/drawingml/2006/main"/>
-          <a:ln xmlns:a="http://schemas.openxmlformats.org/drawingml/2006/main" w="0">
-            <a:noFill/>
-          </a:ln>
-        </p:spPr>
-        <p:txBody>
-          <a:bodyPr xmlns:a="http://schemas.openxmlformats.org/drawingml/2006/main" wrap="square" lIns="0" tIns="0" rIns="0" bIns="0" anchor="t"/>
-          <a:lstStyle xmlns:a="http://schemas.openxmlformats.org/drawingml/2006/main"/>
-          <a:p xmlns:a="http://schemas.openxmlformats.org/drawingml/2006/main">
-            <a:r>
-              <a:rPr lang="en-US" sz="1125" b="1">
-                <a:solidFill>
-                  <a:srgbClr val="0B8EA3"/>
-                </a:solidFill>
-                <a:latin typeface="Arial"/>
-                <a:ea typeface="Arial"/>
-              </a:rPr>
-              <a:t>CARRIER</a:t>
-            </a:r>
-            <a:endParaRPr lang="en-US"/>
-          </a:p>
-        </p:txBody>
-      </p:sp>
-      <p:sp>
-        <p:nvSpPr>
-          <p:cNvPr id="11" name="visual-note-text"/>
-          <p:cNvSpPr txBox="1"/>
-          <p:nvPr/>
-        </p:nvSpPr>
-        <p:spPr>
-          <a:xfrm xmlns:a="http://schemas.openxmlformats.org/drawingml/2006/main">
-            <a:off x="9239250" y="4171950"/>
-            <a:ext cx="4000500" cy="723900"/>
-          </a:xfrm>
-          <a:prstGeom xmlns:a="http://schemas.openxmlformats.org/drawingml/2006/main" prst="rect">
-            <a:avLst/>
-          </a:prstGeom>
-          <a:noFill xmlns:a="http://schemas.openxmlformats.org/drawingml/2006/main"/>
-          <a:ln xmlns:a="http://schemas.openxmlformats.org/drawingml/2006/main" w="0">
-            <a:noFill/>
-          </a:ln>
-        </p:spPr>
-        <p:txBody>
-          <a:bodyPr xmlns:a="http://schemas.openxmlformats.org/drawingml/2006/main" wrap="square" lIns="0" tIns="0" rIns="0" bIns="0" anchor="t"/>
-          <a:lstStyle xmlns:a="http://schemas.openxmlformats.org/drawingml/2006/main"/>
-          <a:p xmlns:a="http://schemas.openxmlformats.org/drawingml/2006/main">
-            <a:r>
-              <a:rPr lang="en-US" sz="2100" b="1">
-                <a:solidFill>
-                  <a:srgbClr val="1D4150"/>
-                </a:solidFill>
-                <a:latin typeface="Arial"/>
-                <a:ea typeface="Arial"/>
-              </a:rPr>
-              <a:t>Subject before slogan</a:t>
-            </a:r>
-            <a:endParaRPr lang="en-US"/>
-          </a:p>
-        </p:txBody>
-      </p:sp>
-      <p:sp>
-        <p:nvSpPr>
-          <p:cNvPr id="12" name="visual-note-foot"/>
-          <p:cNvSpPr txBox="1"/>
-          <p:nvPr/>
-        </p:nvSpPr>
-        <p:spPr>
-          <a:xfrm xmlns:a="http://schemas.openxmlformats.org/drawingml/2006/main">
-            <a:off x="9239250" y="5219700"/>
-            <a:ext cx="4000500" cy="457200"/>
-          </a:xfrm>
-          <a:prstGeom xmlns:a="http://schemas.openxmlformats.org/drawingml/2006/main" prst="rect">
-            <a:avLst/>
-          </a:prstGeom>
-          <a:noFill xmlns:a="http://schemas.openxmlformats.org/drawingml/2006/main"/>
-          <a:ln xmlns:a="http://schemas.openxmlformats.org/drawingml/2006/main" w="0">
-            <a:noFill/>
-          </a:ln>
-        </p:spPr>
-        <p:txBody>
-          <a:bodyPr xmlns:a="http://schemas.openxmlformats.org/drawingml/2006/main" wrap="square" lIns="0" tIns="0" rIns="0" bIns="0" anchor="t"/>
-          <a:lstStyle xmlns:a="http://schemas.openxmlformats.org/drawingml/2006/main"/>
-          <a:p xmlns:a="http://schemas.openxmlformats.org/drawingml/2006/main">
-            <a:r>
-              <a:rPr lang="en-US" sz="1200">
-                <a:solidFill>
-                  <a:srgbClr val="8C9B9D"/>
-                </a:solidFill>
-                <a:latin typeface="Arial"/>
-                <a:ea typeface="Arial"/>
-              </a:rPr>
-              <a:t>Crop, contrast and source role are reviewed before delivery.</a:t>
-            </a:r>
-            <a:endParaRPr lang="en-US"/>
-          </a:p>
-        </p:txBody>
-      </p:sp>
-      <p:sp>
-        <p:nvSpPr>
-          <p:cNvPr id="13" name="source"/>
+              <a:t>THE IMAGE IS EVIDENCE, NOT FILL</a:t>
+            </a:r>
+            <a:endParaRPr lang="en-US"/>
+          </a:p>
+        </p:txBody>
+      </p:sp>
+      <p:sp>
+        <p:nvSpPr>
+          <p:cNvPr id="8" name="source"/>
           <p:cNvSpPr txBox="1"/>
           <p:nvPr/>
         </p:nvSpPr>
@@ -2878,7 +2717,7 @@
       </p:sp>
       <p:sp>
         <p:nvSpPr>
-          <p:cNvPr id="14" name="page-number"/>
+          <p:cNvPr id="9" name="page-number"/>
           <p:cNvSpPr txBox="1"/>
           <p:nvPr/>
         </p:nvSpPr>
@@ -2925,6 +2764,16 @@
 <file path=ppt/slides/slide6.xml><?xml version="1.0" encoding="utf-8"?>
 <p:sld xmlns:p="http://schemas.openxmlformats.org/presentationml/2006/main">
   <p:cSld name="Decision close">
+    <p:bg>
+      <p:bgPr>
+        <a:blipFill xmlns:a="http://schemas.openxmlformats.org/drawingml/2006/main">
+          <a:blip xmlns:r="http://schemas.openxmlformats.org/officeDocument/2006/relationships" r:embed="rIdOfficeKitImage6af8c9b5dff6e3a3_1"/>
+          <a:stretch>
+            <a:fillRect/>
+          </a:stretch>
+        </a:blipFill>
+      </p:bgPr>
+    </p:bg>
     <p:spTree>
       <p:nvGrpSpPr>
         <p:cNvPr id="1" name=""/>
@@ -2941,20 +2790,22 @@
       </p:grpSpPr>
       <p:sp>
         <p:nvSpPr>
-          <p:cNvPr id="2" name="background"/>
+          <p:cNvPr id="2" name="close-paper-scrim"/>
           <p:cNvSpPr/>
           <p:nvPr/>
         </p:nvSpPr>
         <p:spPr>
           <a:xfrm xmlns:a="http://schemas.openxmlformats.org/drawingml/2006/main">
             <a:off x="0" y="0"/>
-            <a:ext cx="15240000" cy="8572500"/>
+            <a:ext cx="8191500" cy="8572500"/>
           </a:xfrm>
           <a:prstGeom xmlns:a="http://schemas.openxmlformats.org/drawingml/2006/main" prst="rect">
             <a:avLst/>
           </a:prstGeom>
           <a:solidFill xmlns:a="http://schemas.openxmlformats.org/drawingml/2006/main">
-            <a:srgbClr val="F3EFE4"/>
+            <a:srgbClr val="F3EFE4">
+              <a:alpha val="96000"/>
+            </a:srgbClr>
           </a:solidFill>
           <a:ln xmlns:a="http://schemas.openxmlformats.org/drawingml/2006/main" w="0">
             <a:solidFill>
@@ -3055,29 +2906,42 @@
         <p:spPr>
           <a:xfrm xmlns:a="http://schemas.openxmlformats.org/drawingml/2006/main">
             <a:off x="914400" y="1314450"/>
-            <a:ext cx="11811000" cy="552450"/>
-          </a:xfrm>
-          <a:prstGeom xmlns:a="http://schemas.openxmlformats.org/drawingml/2006/main" prst="rect">
-            <a:avLst/>
-          </a:prstGeom>
-          <a:noFill xmlns:a="http://schemas.openxmlformats.org/drawingml/2006/main"/>
-          <a:ln xmlns:a="http://schemas.openxmlformats.org/drawingml/2006/main" w="0">
-            <a:noFill/>
-          </a:ln>
-        </p:spPr>
-        <p:txBody>
-          <a:bodyPr xmlns:a="http://schemas.openxmlformats.org/drawingml/2006/main" wrap="square" lIns="0" tIns="0" rIns="0" bIns="0" anchor="t"/>
-          <a:lstStyle xmlns:a="http://schemas.openxmlformats.org/drawingml/2006/main"/>
-          <a:p xmlns:a="http://schemas.openxmlformats.org/drawingml/2006/main">
-            <a:r>
-              <a:rPr lang="en-US" sz="2850" b="1">
+            <a:ext cx="6286500" cy="914400"/>
+          </a:xfrm>
+          <a:prstGeom xmlns:a="http://schemas.openxmlformats.org/drawingml/2006/main" prst="rect">
+            <a:avLst/>
+          </a:prstGeom>
+          <a:noFill xmlns:a="http://schemas.openxmlformats.org/drawingml/2006/main"/>
+          <a:ln xmlns:a="http://schemas.openxmlformats.org/drawingml/2006/main" w="0">
+            <a:noFill/>
+          </a:ln>
+        </p:spPr>
+        <p:txBody>
+          <a:bodyPr xmlns:a="http://schemas.openxmlformats.org/drawingml/2006/main" wrap="square" lIns="0" tIns="0" rIns="0" bIns="0" anchor="t"/>
+          <a:lstStyle xmlns:a="http://schemas.openxmlformats.org/drawingml/2006/main"/>
+          <a:p xmlns:a="http://schemas.openxmlformats.org/drawingml/2006/main">
+            <a:r>
+              <a:rPr lang="en-US" sz="2550" b="1">
                 <a:solidFill>
                   <a:srgbClr val="1D4150"/>
                 </a:solidFill>
                 <a:latin typeface="Arial"/>
                 <a:ea typeface="Arial"/>
               </a:rPr>
-              <a:t>Turn the shared invitation into an action plan</a:t>
+              <a:t>Turn the shared invitation into an</a:t>
+            </a:r>
+            <a:endParaRPr lang="en-US"/>
+          </a:p>
+          <a:p xmlns:a="http://schemas.openxmlformats.org/drawingml/2006/main">
+            <a:r>
+              <a:rPr lang="en-US" sz="2550" b="1">
+                <a:solidFill>
+                  <a:srgbClr val="1D4150"/>
+                </a:solidFill>
+                <a:latin typeface="Arial"/>
+                <a:ea typeface="Arial"/>
+              </a:rPr>
+              <a:t>action plan</a:t>
             </a:r>
             <a:endParaRPr lang="en-US"/>
           </a:p>
@@ -3091,8 +2955,8 @@
         </p:nvSpPr>
         <p:spPr>
           <a:xfrm xmlns:a="http://schemas.openxmlformats.org/drawingml/2006/main">
-            <a:off x="952500" y="1981200"/>
-            <a:ext cx="10477500" cy="266700"/>
+            <a:off x="952500" y="2190750"/>
+            <a:ext cx="6096000" cy="266700"/>
           </a:xfrm>
           <a:prstGeom xmlns:a="http://schemas.openxmlformats.org/drawingml/2006/main" prst="rect">
             <a:avLst/>

</xml_diff>

<commit_message>
feat(templates): diversify image-led reference pools
</commit_message>
<xml_diff>
--- a/skills/presentation-template-library/skills/artifact-template-aqua-impact-story/assets/reference.pptx
+++ b/skills/presentation-template-library/skills/artifact-template-aqua-impact-story/assets/reference.pptx
@@ -357,7 +357,7 @@
     <p:bg>
       <p:bgPr>
         <a:blipFill xmlns:a="http://schemas.openxmlformats.org/drawingml/2006/main">
-          <a:blip xmlns:r="http://schemas.openxmlformats.org/officeDocument/2006/relationships" r:embed="rIdOfficeKitImagebdd32fb5cfa65986_1"/>
+          <a:blip xmlns:r="http://schemas.openxmlformats.org/officeDocument/2006/relationships" r:embed="rIdOfficeKitImagea68aebf613832e5f_1"/>
           <a:stretch>
             <a:fillRect/>
           </a:stretch>
@@ -393,13 +393,13 @@
             <a:avLst/>
           </a:prstGeom>
           <a:solidFill xmlns:a="http://schemas.openxmlformats.org/drawingml/2006/main">
-            <a:srgbClr val="1D4150">
+            <a:srgbClr val="F3EFE4">
               <a:alpha val="84000"/>
             </a:srgbClr>
           </a:solidFill>
           <a:ln xmlns:a="http://schemas.openxmlformats.org/drawingml/2006/main" w="0">
             <a:solidFill>
-              <a:srgbClr val="1D4150"/>
+              <a:srgbClr val="F3EFE4"/>
             </a:solidFill>
             <a:prstDash val="solid"/>
           </a:ln>
@@ -479,7 +479,7 @@
             <a:r>
               <a:rPr lang="en-US" sz="3900" b="1">
                 <a:solidFill>
-                  <a:srgbClr val="FFFFFF"/>
+                  <a:srgbClr val="1D4150"/>
                 </a:solidFill>
                 <a:latin typeface="Arial"/>
                 <a:ea typeface="Arial"/>
@@ -516,7 +516,7 @@
             <a:r>
               <a:rPr lang="en-US" sz="1650">
                 <a:solidFill>
-                  <a:srgbClr val="F0F2F2"/>
+                  <a:srgbClr val="1D4150"/>
                 </a:solidFill>
                 <a:latin typeface="Arial"/>
                 <a:ea typeface="Arial"/>
@@ -587,7 +587,7 @@
             <a:r>
               <a:rPr lang="en-US" sz="1950" b="1">
                 <a:solidFill>
-                  <a:srgbClr val="FFFFFF"/>
+                  <a:srgbClr val="1D4150"/>
                 </a:solidFill>
                 <a:latin typeface="Arial"/>
                 <a:ea typeface="Arial"/>
@@ -624,7 +624,7 @@
             <a:r>
               <a:rPr lang="en-US" sz="1050">
                 <a:solidFill>
-                  <a:srgbClr val="F0F2F2"/>
+                  <a:srgbClr val="1D4150"/>
                 </a:solidFill>
                 <a:latin typeface="Arial"/>
                 <a:ea typeface="Arial"/>
@@ -662,7 +662,7 @@
             <a:r>
               <a:rPr lang="en-US" sz="1050">
                 <a:solidFill>
-                  <a:srgbClr val="F0F2F2"/>
+                  <a:srgbClr val="1D4150"/>
                 </a:solidFill>
                 <a:latin typeface="Arial"/>
                 <a:ea typeface="Arial"/>
@@ -687,7 +687,7 @@
     <p:bg>
       <p:bgPr>
         <a:blipFill xmlns:a="http://schemas.openxmlformats.org/drawingml/2006/main">
-          <a:blip xmlns:r="http://schemas.openxmlformats.org/officeDocument/2006/relationships" r:embed="rIdOfficeKitImagec7b73f8fac405495_1"/>
+          <a:blip xmlns:r="http://schemas.openxmlformats.org/officeDocument/2006/relationships" r:embed="rIdOfficeKitImage6785cc6781fd2511_1"/>
           <a:stretch>
             <a:fillRect/>
           </a:stretch>
@@ -1062,7 +1062,7 @@
           <p:nvPr/>
         </p:nvPicPr>
         <p:blipFill>
-          <a:blip xmlns:r="http://schemas.openxmlformats.org/officeDocument/2006/relationships" xmlns:a="http://schemas.openxmlformats.org/drawingml/2006/main" r:embed="rIdOfficeKitImage026be3a43029630d_1"/>
+          <a:blip xmlns:r="http://schemas.openxmlformats.org/officeDocument/2006/relationships" xmlns:a="http://schemas.openxmlformats.org/drawingml/2006/main" r:embed="rIdOfficeKitImagee930dcb9c6b95953_1"/>
           <a:srcRect xmlns:a="http://schemas.openxmlformats.org/drawingml/2006/main" l="0" t="31920" r="0" b="31920"/>
           <a:stretch xmlns:a="http://schemas.openxmlformats.org/drawingml/2006/main">
             <a:fillRect/>
@@ -1238,7 +1238,7 @@
     <p:bg>
       <p:bgPr>
         <a:blipFill xmlns:a="http://schemas.openxmlformats.org/drawingml/2006/main">
-          <a:blip xmlns:r="http://schemas.openxmlformats.org/officeDocument/2006/relationships" r:embed="rIdOfficeKitImage092dd3ee80187530_1"/>
+          <a:blip xmlns:r="http://schemas.openxmlformats.org/officeDocument/2006/relationships" r:embed="rIdOfficeKitImage5e425a7c66b022d4_1"/>
           <a:stretch>
             <a:fillRect/>
           </a:stretch>
@@ -1503,7 +1503,7 @@
         </p:xfrm>
         <a:graphic xmlns:a="http://schemas.openxmlformats.org/drawingml/2006/main">
           <a:graphicData uri="http://schemas.openxmlformats.org/drawingml/2006/chart">
-            <c:chart xmlns:r="http://schemas.openxmlformats.org/officeDocument/2006/relationships" xmlns:c="http://schemas.openxmlformats.org/drawingml/2006/chart" r:id="R4725cb4629584397"/>
+            <c:chart xmlns:r="http://schemas.openxmlformats.org/officeDocument/2006/relationships" xmlns:c="http://schemas.openxmlformats.org/drawingml/2006/chart" r:id="R7d3b8a5e9a4146ac"/>
           </a:graphicData>
         </a:graphic>
       </p:graphicFrame>
@@ -2079,7 +2079,7 @@
           <p:nvPr/>
         </p:nvPicPr>
         <p:blipFill>
-          <a:blip xmlns:r="http://schemas.openxmlformats.org/officeDocument/2006/relationships" xmlns:a="http://schemas.openxmlformats.org/drawingml/2006/main" r:embed="rIdOfficeKitImage7790b68b5d8fcd92_1"/>
+          <a:blip xmlns:r="http://schemas.openxmlformats.org/officeDocument/2006/relationships" xmlns:a="http://schemas.openxmlformats.org/drawingml/2006/main" r:embed="rIdOfficeKitImage84ff976f39aab728_1"/>
           <a:srcRect xmlns:a="http://schemas.openxmlformats.org/drawingml/2006/main" l="0" t="31971" r="0" b="31971"/>
           <a:stretch xmlns:a="http://schemas.openxmlformats.org/drawingml/2006/main">
             <a:fillRect/>
@@ -2108,8 +2108,8 @@
           <p:nvPr/>
         </p:nvPicPr>
         <p:blipFill>
-          <a:blip xmlns:r="http://schemas.openxmlformats.org/officeDocument/2006/relationships" xmlns:a="http://schemas.openxmlformats.org/drawingml/2006/main" r:embed="rIdOfficeKitImaged3ade97fd9ca0fdd_1"/>
-          <a:srcRect xmlns:a="http://schemas.openxmlformats.org/drawingml/2006/main" l="0" t="32338" r="0" b="32338"/>
+          <a:blip xmlns:r="http://schemas.openxmlformats.org/officeDocument/2006/relationships" xmlns:a="http://schemas.openxmlformats.org/drawingml/2006/main" r:embed="rIdOfficeKitImage20fc6993425855c3_1"/>
+          <a:srcRect xmlns:a="http://schemas.openxmlformats.org/drawingml/2006/main" l="0" t="32333" r="0" b="32333"/>
           <a:stretch xmlns:a="http://schemas.openxmlformats.org/drawingml/2006/main">
             <a:fillRect/>
           </a:stretch>
@@ -2137,8 +2137,8 @@
           <p:nvPr/>
         </p:nvPicPr>
         <p:blipFill>
-          <a:blip xmlns:r="http://schemas.openxmlformats.org/officeDocument/2006/relationships" xmlns:a="http://schemas.openxmlformats.org/drawingml/2006/main" r:embed="rIdOfficeKitImagebdd32fb5cfa65986_1"/>
-          <a:srcRect xmlns:a="http://schemas.openxmlformats.org/drawingml/2006/main" l="0" t="32347" r="0" b="32347"/>
+          <a:blip xmlns:r="http://schemas.openxmlformats.org/officeDocument/2006/relationships" xmlns:a="http://schemas.openxmlformats.org/drawingml/2006/main" r:embed="rIdOfficeKitImagee977612ad933c986_1"/>
+          <a:srcRect xmlns:a="http://schemas.openxmlformats.org/drawingml/2006/main" l="0" t="32333" r="0" b="32333"/>
           <a:stretch xmlns:a="http://schemas.openxmlformats.org/drawingml/2006/main">
             <a:fillRect/>
           </a:stretch>
@@ -2166,8 +2166,8 @@
           <p:nvPr/>
         </p:nvPicPr>
         <p:blipFill>
-          <a:blip xmlns:r="http://schemas.openxmlformats.org/officeDocument/2006/relationships" xmlns:a="http://schemas.openxmlformats.org/drawingml/2006/main" r:embed="rIdOfficeKitImagec7b73f8fac405495_1"/>
-          <a:srcRect xmlns:a="http://schemas.openxmlformats.org/drawingml/2006/main" l="0" t="32338" r="0" b="32338"/>
+          <a:blip xmlns:r="http://schemas.openxmlformats.org/officeDocument/2006/relationships" xmlns:a="http://schemas.openxmlformats.org/drawingml/2006/main" r:embed="rIdOfficeKitImaged96cedd8678b85ac_1"/>
+          <a:srcRect xmlns:a="http://schemas.openxmlformats.org/drawingml/2006/main" l="0" t="32347" r="0" b="32347"/>
           <a:stretch xmlns:a="http://schemas.openxmlformats.org/drawingml/2006/main">
             <a:fillRect/>
           </a:stretch>
@@ -2195,7 +2195,7 @@
           <p:nvPr/>
         </p:nvPicPr>
         <p:blipFill>
-          <a:blip xmlns:r="http://schemas.openxmlformats.org/officeDocument/2006/relationships" xmlns:a="http://schemas.openxmlformats.org/drawingml/2006/main" r:embed="rIdOfficeKitImage026be3a43029630d_1"/>
+          <a:blip xmlns:r="http://schemas.openxmlformats.org/officeDocument/2006/relationships" xmlns:a="http://schemas.openxmlformats.org/drawingml/2006/main" r:embed="rIdOfficeKitImage35d943dc999c7d05_1"/>
           <a:srcRect xmlns:a="http://schemas.openxmlformats.org/drawingml/2006/main" l="0" t="32347" r="0" b="32347"/>
           <a:stretch xmlns:a="http://schemas.openxmlformats.org/drawingml/2006/main">
             <a:fillRect/>
@@ -2434,10 +2434,359 @@
 <file path=ppt/slides/slide5.xml><?xml version="1.0" encoding="utf-8"?>
 <p:sld xmlns:p="http://schemas.openxmlformats.org/presentationml/2006/main">
   <p:cSld name="Visual carrier">
+    <p:spTree>
+      <p:nvGrpSpPr>
+        <p:cNvPr id="1" name=""/>
+        <p:cNvGrpSpPr/>
+        <p:nvPr/>
+      </p:nvGrpSpPr>
+      <p:grpSpPr>
+        <a:xfrm xmlns:a="http://schemas.openxmlformats.org/drawingml/2006/main">
+          <a:off x="0" y="0"/>
+          <a:ext cx="0" cy="0"/>
+          <a:chOff x="0" y="0"/>
+          <a:chExt cx="0" cy="0"/>
+        </a:xfrm>
+      </p:grpSpPr>
+      <p:pic>
+        <p:nvPicPr>
+          <p:cNvPr id="2" name="visual-visual-field">
+            <a:extLst xmlns:a="http://schemas.openxmlformats.org/drawingml/2006/main">
+              <a:ext uri="{C183D7F6-B498-43B3-948B-1728B52AA6E4}">
+                <adec:decorative xmlns:adec="http://schemas.microsoft.com/office/drawing/2017/decorative" val="1"/>
+              </a:ext>
+            </a:extLst>
+          </p:cNvPr>
+          <p:cNvPicPr/>
+          <p:nvPr/>
+        </p:nvPicPr>
+        <p:blipFill>
+          <a:blip xmlns:r="http://schemas.openxmlformats.org/officeDocument/2006/relationships" xmlns:a="http://schemas.openxmlformats.org/drawingml/2006/main" r:embed="rIdOfficeKitImagedf986129197cef3b_1"/>
+          <a:srcRect xmlns:a="http://schemas.openxmlformats.org/drawingml/2006/main" l="0" t="34180" r="0" b="34180"/>
+          <a:stretch xmlns:a="http://schemas.openxmlformats.org/drawingml/2006/main">
+            <a:fillRect/>
+          </a:stretch>
+        </p:blipFill>
+        <p:spPr>
+          <a:xfrm xmlns:a="http://schemas.openxmlformats.org/drawingml/2006/main" flipH="1">
+            <a:off x="0" y="0"/>
+            <a:ext cx="15240000" cy="8572500"/>
+          </a:xfrm>
+          <a:prstGeom xmlns:a="http://schemas.openxmlformats.org/drawingml/2006/main" prst="rect">
+            <a:avLst/>
+          </a:prstGeom>
+        </p:spPr>
+      </p:pic>
+      <p:sp>
+        <p:nvSpPr>
+          <p:cNvPr id="3" name="visual-scrim"/>
+          <p:cNvSpPr/>
+          <p:nvPr/>
+        </p:nvSpPr>
+        <p:spPr>
+          <a:xfrm xmlns:a="http://schemas.openxmlformats.org/drawingml/2006/main">
+            <a:off x="0" y="0"/>
+            <a:ext cx="6858000" cy="8572500"/>
+          </a:xfrm>
+          <a:prstGeom xmlns:a="http://schemas.openxmlformats.org/drawingml/2006/main" prst="rect">
+            <a:avLst/>
+          </a:prstGeom>
+          <a:solidFill xmlns:a="http://schemas.openxmlformats.org/drawingml/2006/main">
+            <a:srgbClr val="F3EFE4">
+              <a:alpha val="88000"/>
+            </a:srgbClr>
+          </a:solidFill>
+          <a:ln xmlns:a="http://schemas.openxmlformats.org/drawingml/2006/main" w="0">
+            <a:solidFill>
+              <a:srgbClr val="F3EFE4"/>
+            </a:solidFill>
+            <a:prstDash val="solid"/>
+          </a:ln>
+        </p:spPr>
+        <p:txBody>
+          <a:bodyPr xmlns:a="http://schemas.openxmlformats.org/drawingml/2006/main" wrap="square" lIns="0" tIns="0" rIns="0" bIns="0" anchor="t"/>
+          <a:lstStyle xmlns:a="http://schemas.openxmlformats.org/drawingml/2006/main"/>
+          <a:p xmlns:a="http://schemas.openxmlformats.org/drawingml/2006/main">
+            <a:r>
+              <a:rPr lang="en-US"/>
+              <a:t/>
+            </a:r>
+            <a:endParaRPr lang="en-US"/>
+          </a:p>
+        </p:txBody>
+      </p:sp>
+      <p:sp>
+        <p:nvSpPr>
+          <p:cNvPr id="4" name="visual-eyebrow"/>
+          <p:cNvSpPr txBox="1"/>
+          <p:nvPr/>
+        </p:nvSpPr>
+        <p:spPr>
+          <a:xfrm xmlns:a="http://schemas.openxmlformats.org/drawingml/2006/main">
+            <a:off x="914400" y="895350"/>
+            <a:ext cx="6667500" cy="228600"/>
+          </a:xfrm>
+          <a:prstGeom xmlns:a="http://schemas.openxmlformats.org/drawingml/2006/main" prst="rect">
+            <a:avLst/>
+          </a:prstGeom>
+          <a:noFill xmlns:a="http://schemas.openxmlformats.org/drawingml/2006/main"/>
+          <a:ln xmlns:a="http://schemas.openxmlformats.org/drawingml/2006/main" w="0">
+            <a:noFill/>
+          </a:ln>
+        </p:spPr>
+        <p:txBody>
+          <a:bodyPr xmlns:a="http://schemas.openxmlformats.org/drawingml/2006/main" wrap="square" lIns="0" tIns="0" rIns="0" bIns="0" anchor="t"/>
+          <a:lstStyle xmlns:a="http://schemas.openxmlformats.org/drawingml/2006/main"/>
+          <a:p xmlns:a="http://schemas.openxmlformats.org/drawingml/2006/main">
+            <a:r>
+              <a:rPr lang="en-US" sz="1200" b="1">
+                <a:solidFill>
+                  <a:srgbClr val="0B8EA3"/>
+                </a:solidFill>
+                <a:latin typeface="Arial"/>
+                <a:ea typeface="Arial"/>
+              </a:rPr>
+              <a:t>AQUA IMPACT STORY · VISUAL CARRIER</a:t>
+            </a:r>
+            <a:endParaRPr lang="en-US"/>
+          </a:p>
+        </p:txBody>
+      </p:sp>
+      <p:sp>
+        <p:nvSpPr>
+          <p:cNvPr id="5" name="visual-title"/>
+          <p:cNvSpPr txBox="1"/>
+          <p:nvPr/>
+        </p:nvSpPr>
+        <p:spPr>
+          <a:xfrm xmlns:a="http://schemas.openxmlformats.org/drawingml/2006/main">
+            <a:off x="914400" y="1638300"/>
+            <a:ext cx="5334000" cy="1143000"/>
+          </a:xfrm>
+          <a:prstGeom xmlns:a="http://schemas.openxmlformats.org/drawingml/2006/main" prst="rect">
+            <a:avLst/>
+          </a:prstGeom>
+          <a:noFill xmlns:a="http://schemas.openxmlformats.org/drawingml/2006/main"/>
+          <a:ln xmlns:a="http://schemas.openxmlformats.org/drawingml/2006/main" w="0">
+            <a:noFill/>
+          </a:ln>
+        </p:spPr>
+        <p:txBody>
+          <a:bodyPr xmlns:a="http://schemas.openxmlformats.org/drawingml/2006/main" wrap="square" lIns="0" tIns="0" rIns="0" bIns="0" anchor="t"/>
+          <a:lstStyle xmlns:a="http://schemas.openxmlformats.org/drawingml/2006/main"/>
+          <a:p xmlns:a="http://schemas.openxmlformats.org/drawingml/2006/main">
+            <a:r>
+              <a:rPr lang="en-US" sz="3300" b="1">
+                <a:solidFill>
+                  <a:srgbClr val="1D4150"/>
+                </a:solidFill>
+                <a:latin typeface="Arial"/>
+                <a:ea typeface="Arial"/>
+              </a:rPr>
+              <a:t>Let the subject do the work</a:t>
+            </a:r>
+            <a:endParaRPr lang="en-US"/>
+          </a:p>
+        </p:txBody>
+      </p:sp>
+      <p:sp>
+        <p:nvSpPr>
+          <p:cNvPr id="6" name="visual-body"/>
+          <p:cNvSpPr txBox="1"/>
+          <p:nvPr/>
+        </p:nvSpPr>
+        <p:spPr>
+          <a:xfrm xmlns:a="http://schemas.openxmlformats.org/drawingml/2006/main">
+            <a:off x="914400" y="3219450"/>
+            <a:ext cx="4762500" cy="685800"/>
+          </a:xfrm>
+          <a:prstGeom xmlns:a="http://schemas.openxmlformats.org/drawingml/2006/main" prst="rect">
+            <a:avLst/>
+          </a:prstGeom>
+          <a:noFill xmlns:a="http://schemas.openxmlformats.org/drawingml/2006/main"/>
+          <a:ln xmlns:a="http://schemas.openxmlformats.org/drawingml/2006/main" w="0">
+            <a:noFill/>
+          </a:ln>
+        </p:spPr>
+        <p:txBody>
+          <a:bodyPr xmlns:a="http://schemas.openxmlformats.org/drawingml/2006/main" wrap="square" lIns="0" tIns="0" rIns="0" bIns="0" anchor="t"/>
+          <a:lstStyle xmlns:a="http://schemas.openxmlformats.org/drawingml/2006/main"/>
+          <a:p xmlns:a="http://schemas.openxmlformats.org/drawingml/2006/main">
+            <a:r>
+              <a:rPr lang="en-US" sz="1800">
+                <a:solidFill>
+                  <a:srgbClr val="1D4150"/>
+                </a:solidFill>
+                <a:latin typeface="Arial"/>
+                <a:ea typeface="Arial"/>
+              </a:rPr>
+              <a:t>A strong crop gives the proposition a place to live.</a:t>
+            </a:r>
+            <a:endParaRPr lang="en-US"/>
+          </a:p>
+        </p:txBody>
+      </p:sp>
+      <p:sp>
+        <p:nvSpPr>
+          <p:cNvPr id="7" name="visual-rule"/>
+          <p:cNvSpPr/>
+          <p:nvPr/>
+        </p:nvSpPr>
+        <p:spPr>
+          <a:xfrm xmlns:a="http://schemas.openxmlformats.org/drawingml/2006/main">
+            <a:off x="914400" y="4476750"/>
+            <a:ext cx="4419600" cy="0"/>
+          </a:xfrm>
+          <a:prstGeom xmlns:a="http://schemas.openxmlformats.org/drawingml/2006/main" prst="line">
+            <a:avLst/>
+          </a:prstGeom>
+          <a:noFill xmlns:a="http://schemas.openxmlformats.org/drawingml/2006/main"/>
+          <a:ln xmlns:a="http://schemas.openxmlformats.org/drawingml/2006/main" w="38100">
+            <a:solidFill>
+              <a:srgbClr val="0B8EA3"/>
+            </a:solidFill>
+            <a:prstDash val="solid"/>
+          </a:ln>
+        </p:spPr>
+        <p:txBody>
+          <a:bodyPr xmlns:a="http://schemas.openxmlformats.org/drawingml/2006/main" wrap="square" lIns="0" tIns="0" rIns="0" bIns="0" anchor="t"/>
+          <a:lstStyle xmlns:a="http://schemas.openxmlformats.org/drawingml/2006/main"/>
+          <a:p xmlns:a="http://schemas.openxmlformats.org/drawingml/2006/main">
+            <a:r>
+              <a:rPr lang="en-US"/>
+              <a:t/>
+            </a:r>
+            <a:endParaRPr lang="en-US"/>
+          </a:p>
+        </p:txBody>
+      </p:sp>
+      <p:sp>
+        <p:nvSpPr>
+          <p:cNvPr id="8" name="visual-label"/>
+          <p:cNvSpPr txBox="1"/>
+          <p:nvPr/>
+        </p:nvSpPr>
+        <p:spPr>
+          <a:xfrm xmlns:a="http://schemas.openxmlformats.org/drawingml/2006/main">
+            <a:off x="914400" y="4819650"/>
+            <a:ext cx="4953000" cy="228600"/>
+          </a:xfrm>
+          <a:prstGeom xmlns:a="http://schemas.openxmlformats.org/drawingml/2006/main" prst="rect">
+            <a:avLst/>
+          </a:prstGeom>
+          <a:noFill xmlns:a="http://schemas.openxmlformats.org/drawingml/2006/main"/>
+          <a:ln xmlns:a="http://schemas.openxmlformats.org/drawingml/2006/main" w="0">
+            <a:noFill/>
+          </a:ln>
+        </p:spPr>
+        <p:txBody>
+          <a:bodyPr xmlns:a="http://schemas.openxmlformats.org/drawingml/2006/main" wrap="square" lIns="0" tIns="0" rIns="0" bIns="0" anchor="t"/>
+          <a:lstStyle xmlns:a="http://schemas.openxmlformats.org/drawingml/2006/main"/>
+          <a:p xmlns:a="http://schemas.openxmlformats.org/drawingml/2006/main">
+            <a:r>
+              <a:rPr lang="en-US" sz="1200" b="1">
+                <a:solidFill>
+                  <a:srgbClr val="0B8EA3"/>
+                </a:solidFill>
+                <a:latin typeface="Arial"/>
+                <a:ea typeface="Arial"/>
+              </a:rPr>
+              <a:t>THE IMAGE IS EVIDENCE, NOT FILL</a:t>
+            </a:r>
+            <a:endParaRPr lang="en-US"/>
+          </a:p>
+        </p:txBody>
+      </p:sp>
+      <p:sp>
+        <p:nvSpPr>
+          <p:cNvPr id="9" name="source"/>
+          <p:cNvSpPr txBox="1"/>
+          <p:nvPr/>
+        </p:nvSpPr>
+        <p:spPr>
+          <a:xfrm xmlns:a="http://schemas.openxmlformats.org/drawingml/2006/main">
+            <a:off x="914400" y="7829550"/>
+            <a:ext cx="10953750" cy="209550"/>
+          </a:xfrm>
+          <a:prstGeom xmlns:a="http://schemas.openxmlformats.org/drawingml/2006/main" prst="rect">
+            <a:avLst/>
+          </a:prstGeom>
+          <a:noFill xmlns:a="http://schemas.openxmlformats.org/drawingml/2006/main"/>
+          <a:ln xmlns:a="http://schemas.openxmlformats.org/drawingml/2006/main" w="0">
+            <a:noFill/>
+          </a:ln>
+        </p:spPr>
+        <p:txBody>
+          <a:bodyPr xmlns:a="http://schemas.openxmlformats.org/drawingml/2006/main" wrap="square" lIns="0" tIns="0" rIns="0" bIns="0" anchor="t"/>
+          <a:lstStyle xmlns:a="http://schemas.openxmlformats.org/drawingml/2006/main"/>
+          <a:p xmlns:a="http://schemas.openxmlformats.org/drawingml/2006/main">
+            <a:r>
+              <a:rPr lang="en-US" sz="1050">
+                <a:solidFill>
+                  <a:srgbClr val="8C9B9D"/>
+                </a:solidFill>
+                <a:latin typeface="Arial"/>
+                <a:ea typeface="Arial"/>
+              </a:rPr>
+              <a:t>OfficeKit original clean-room visual field · fictional content</a:t>
+            </a:r>
+            <a:endParaRPr lang="en-US"/>
+          </a:p>
+        </p:txBody>
+      </p:sp>
+      <p:sp>
+        <p:nvSpPr>
+          <p:cNvPr id="10" name="page-number"/>
+          <p:cNvSpPr txBox="1"/>
+          <p:nvPr/>
+        </p:nvSpPr>
+        <p:spPr>
+          <a:xfrm xmlns:a="http://schemas.openxmlformats.org/drawingml/2006/main">
+            <a:off x="13335000" y="7829550"/>
+            <a:ext cx="952500" cy="209550"/>
+          </a:xfrm>
+          <a:prstGeom xmlns:a="http://schemas.openxmlformats.org/drawingml/2006/main" prst="rect">
+            <a:avLst/>
+          </a:prstGeom>
+          <a:noFill xmlns:a="http://schemas.openxmlformats.org/drawingml/2006/main"/>
+          <a:ln xmlns:a="http://schemas.openxmlformats.org/drawingml/2006/main" w="0">
+            <a:noFill/>
+          </a:ln>
+        </p:spPr>
+        <p:txBody>
+          <a:bodyPr xmlns:a="http://schemas.openxmlformats.org/drawingml/2006/main" wrap="square" lIns="0" tIns="0" rIns="0" bIns="0" anchor="t"/>
+          <a:lstStyle xmlns:a="http://schemas.openxmlformats.org/drawingml/2006/main"/>
+          <a:p xmlns:a="http://schemas.openxmlformats.org/drawingml/2006/main">
+            <a:pPr algn="r"/>
+            <a:r>
+              <a:rPr lang="en-US" sz="1050">
+                <a:solidFill>
+                  <a:srgbClr val="8C9B9D"/>
+                </a:solidFill>
+                <a:latin typeface="Arial"/>
+                <a:ea typeface="Arial"/>
+              </a:rPr>
+              <a:t>5 / 6</a:t>
+            </a:r>
+            <a:endParaRPr lang="en-US"/>
+          </a:p>
+        </p:txBody>
+      </p:sp>
+    </p:spTree>
+  </p:cSld>
+  <p:clrMapOvr>
+    <a:masterClrMapping xmlns:a="http://schemas.openxmlformats.org/drawingml/2006/main"/>
+  </p:clrMapOvr>
+</p:sld>
+</file>
+
+<file path=ppt/slides/slide6.xml><?xml version="1.0" encoding="utf-8"?>
+<p:sld xmlns:p="http://schemas.openxmlformats.org/presentationml/2006/main">
+  <p:cSld name="Decision close">
     <p:bg>
       <p:bgPr>
         <a:blipFill xmlns:a="http://schemas.openxmlformats.org/drawingml/2006/main">
-          <a:blip xmlns:r="http://schemas.openxmlformats.org/officeDocument/2006/relationships" r:embed="rIdOfficeKitImage092dd3ee80187530_1"/>
+          <a:blip xmlns:r="http://schemas.openxmlformats.org/officeDocument/2006/relationships" r:embed="rIdOfficeKitImagecb4e39f1eccfa545_1"/>
           <a:stretch>
             <a:fillRect/>
           </a:stretch>
@@ -2460,336 +2809,6 @@
       </p:grpSpPr>
       <p:sp>
         <p:nvSpPr>
-          <p:cNvPr id="2" name="visual-scrim"/>
-          <p:cNvSpPr/>
-          <p:nvPr/>
-        </p:nvSpPr>
-        <p:spPr>
-          <a:xfrm xmlns:a="http://schemas.openxmlformats.org/drawingml/2006/main">
-            <a:off x="0" y="0"/>
-            <a:ext cx="6858000" cy="8572500"/>
-          </a:xfrm>
-          <a:prstGeom xmlns:a="http://schemas.openxmlformats.org/drawingml/2006/main" prst="rect">
-            <a:avLst/>
-          </a:prstGeom>
-          <a:solidFill xmlns:a="http://schemas.openxmlformats.org/drawingml/2006/main">
-            <a:srgbClr val="F3EFE4">
-              <a:alpha val="88000"/>
-            </a:srgbClr>
-          </a:solidFill>
-          <a:ln xmlns:a="http://schemas.openxmlformats.org/drawingml/2006/main" w="0">
-            <a:solidFill>
-              <a:srgbClr val="F3EFE4"/>
-            </a:solidFill>
-            <a:prstDash val="solid"/>
-          </a:ln>
-        </p:spPr>
-        <p:txBody>
-          <a:bodyPr xmlns:a="http://schemas.openxmlformats.org/drawingml/2006/main" wrap="square" lIns="0" tIns="0" rIns="0" bIns="0" anchor="t"/>
-          <a:lstStyle xmlns:a="http://schemas.openxmlformats.org/drawingml/2006/main"/>
-          <a:p xmlns:a="http://schemas.openxmlformats.org/drawingml/2006/main">
-            <a:r>
-              <a:rPr lang="en-US"/>
-              <a:t/>
-            </a:r>
-            <a:endParaRPr lang="en-US"/>
-          </a:p>
-        </p:txBody>
-      </p:sp>
-      <p:sp>
-        <p:nvSpPr>
-          <p:cNvPr id="3" name="visual-eyebrow"/>
-          <p:cNvSpPr txBox="1"/>
-          <p:nvPr/>
-        </p:nvSpPr>
-        <p:spPr>
-          <a:xfrm xmlns:a="http://schemas.openxmlformats.org/drawingml/2006/main">
-            <a:off x="914400" y="895350"/>
-            <a:ext cx="6667500" cy="228600"/>
-          </a:xfrm>
-          <a:prstGeom xmlns:a="http://schemas.openxmlformats.org/drawingml/2006/main" prst="rect">
-            <a:avLst/>
-          </a:prstGeom>
-          <a:noFill xmlns:a="http://schemas.openxmlformats.org/drawingml/2006/main"/>
-          <a:ln xmlns:a="http://schemas.openxmlformats.org/drawingml/2006/main" w="0">
-            <a:noFill/>
-          </a:ln>
-        </p:spPr>
-        <p:txBody>
-          <a:bodyPr xmlns:a="http://schemas.openxmlformats.org/drawingml/2006/main" wrap="square" lIns="0" tIns="0" rIns="0" bIns="0" anchor="t"/>
-          <a:lstStyle xmlns:a="http://schemas.openxmlformats.org/drawingml/2006/main"/>
-          <a:p xmlns:a="http://schemas.openxmlformats.org/drawingml/2006/main">
-            <a:r>
-              <a:rPr lang="en-US" sz="1200" b="1">
-                <a:solidFill>
-                  <a:srgbClr val="0B8EA3"/>
-                </a:solidFill>
-                <a:latin typeface="Arial"/>
-                <a:ea typeface="Arial"/>
-              </a:rPr>
-              <a:t>AQUA IMPACT STORY · VISUAL CARRIER</a:t>
-            </a:r>
-            <a:endParaRPr lang="en-US"/>
-          </a:p>
-        </p:txBody>
-      </p:sp>
-      <p:sp>
-        <p:nvSpPr>
-          <p:cNvPr id="4" name="visual-title"/>
-          <p:cNvSpPr txBox="1"/>
-          <p:nvPr/>
-        </p:nvSpPr>
-        <p:spPr>
-          <a:xfrm xmlns:a="http://schemas.openxmlformats.org/drawingml/2006/main">
-            <a:off x="914400" y="1638300"/>
-            <a:ext cx="5334000" cy="1143000"/>
-          </a:xfrm>
-          <a:prstGeom xmlns:a="http://schemas.openxmlformats.org/drawingml/2006/main" prst="rect">
-            <a:avLst/>
-          </a:prstGeom>
-          <a:noFill xmlns:a="http://schemas.openxmlformats.org/drawingml/2006/main"/>
-          <a:ln xmlns:a="http://schemas.openxmlformats.org/drawingml/2006/main" w="0">
-            <a:noFill/>
-          </a:ln>
-        </p:spPr>
-        <p:txBody>
-          <a:bodyPr xmlns:a="http://schemas.openxmlformats.org/drawingml/2006/main" wrap="square" lIns="0" tIns="0" rIns="0" bIns="0" anchor="t"/>
-          <a:lstStyle xmlns:a="http://schemas.openxmlformats.org/drawingml/2006/main"/>
-          <a:p xmlns:a="http://schemas.openxmlformats.org/drawingml/2006/main">
-            <a:r>
-              <a:rPr lang="en-US" sz="3300" b="1">
-                <a:solidFill>
-                  <a:srgbClr val="1D4150"/>
-                </a:solidFill>
-                <a:latin typeface="Arial"/>
-                <a:ea typeface="Arial"/>
-              </a:rPr>
-              <a:t>Let the subject do the work</a:t>
-            </a:r>
-            <a:endParaRPr lang="en-US"/>
-          </a:p>
-        </p:txBody>
-      </p:sp>
-      <p:sp>
-        <p:nvSpPr>
-          <p:cNvPr id="5" name="visual-body"/>
-          <p:cNvSpPr txBox="1"/>
-          <p:nvPr/>
-        </p:nvSpPr>
-        <p:spPr>
-          <a:xfrm xmlns:a="http://schemas.openxmlformats.org/drawingml/2006/main">
-            <a:off x="914400" y="3219450"/>
-            <a:ext cx="4762500" cy="685800"/>
-          </a:xfrm>
-          <a:prstGeom xmlns:a="http://schemas.openxmlformats.org/drawingml/2006/main" prst="rect">
-            <a:avLst/>
-          </a:prstGeom>
-          <a:noFill xmlns:a="http://schemas.openxmlformats.org/drawingml/2006/main"/>
-          <a:ln xmlns:a="http://schemas.openxmlformats.org/drawingml/2006/main" w="0">
-            <a:noFill/>
-          </a:ln>
-        </p:spPr>
-        <p:txBody>
-          <a:bodyPr xmlns:a="http://schemas.openxmlformats.org/drawingml/2006/main" wrap="square" lIns="0" tIns="0" rIns="0" bIns="0" anchor="t"/>
-          <a:lstStyle xmlns:a="http://schemas.openxmlformats.org/drawingml/2006/main"/>
-          <a:p xmlns:a="http://schemas.openxmlformats.org/drawingml/2006/main">
-            <a:r>
-              <a:rPr lang="en-US" sz="1800">
-                <a:solidFill>
-                  <a:srgbClr val="1D4150"/>
-                </a:solidFill>
-                <a:latin typeface="Arial"/>
-                <a:ea typeface="Arial"/>
-              </a:rPr>
-              <a:t>A strong crop gives the proposition a place to live.</a:t>
-            </a:r>
-            <a:endParaRPr lang="en-US"/>
-          </a:p>
-        </p:txBody>
-      </p:sp>
-      <p:sp>
-        <p:nvSpPr>
-          <p:cNvPr id="6" name="visual-rule"/>
-          <p:cNvSpPr/>
-          <p:nvPr/>
-        </p:nvSpPr>
-        <p:spPr>
-          <a:xfrm xmlns:a="http://schemas.openxmlformats.org/drawingml/2006/main">
-            <a:off x="914400" y="4476750"/>
-            <a:ext cx="4419600" cy="0"/>
-          </a:xfrm>
-          <a:prstGeom xmlns:a="http://schemas.openxmlformats.org/drawingml/2006/main" prst="line">
-            <a:avLst/>
-          </a:prstGeom>
-          <a:noFill xmlns:a="http://schemas.openxmlformats.org/drawingml/2006/main"/>
-          <a:ln xmlns:a="http://schemas.openxmlformats.org/drawingml/2006/main" w="38100">
-            <a:solidFill>
-              <a:srgbClr val="0B8EA3"/>
-            </a:solidFill>
-            <a:prstDash val="solid"/>
-          </a:ln>
-        </p:spPr>
-        <p:txBody>
-          <a:bodyPr xmlns:a="http://schemas.openxmlformats.org/drawingml/2006/main" wrap="square" lIns="0" tIns="0" rIns="0" bIns="0" anchor="t"/>
-          <a:lstStyle xmlns:a="http://schemas.openxmlformats.org/drawingml/2006/main"/>
-          <a:p xmlns:a="http://schemas.openxmlformats.org/drawingml/2006/main">
-            <a:r>
-              <a:rPr lang="en-US"/>
-              <a:t/>
-            </a:r>
-            <a:endParaRPr lang="en-US"/>
-          </a:p>
-        </p:txBody>
-      </p:sp>
-      <p:sp>
-        <p:nvSpPr>
-          <p:cNvPr id="7" name="visual-label"/>
-          <p:cNvSpPr txBox="1"/>
-          <p:nvPr/>
-        </p:nvSpPr>
-        <p:spPr>
-          <a:xfrm xmlns:a="http://schemas.openxmlformats.org/drawingml/2006/main">
-            <a:off x="914400" y="4819650"/>
-            <a:ext cx="4953000" cy="228600"/>
-          </a:xfrm>
-          <a:prstGeom xmlns:a="http://schemas.openxmlformats.org/drawingml/2006/main" prst="rect">
-            <a:avLst/>
-          </a:prstGeom>
-          <a:noFill xmlns:a="http://schemas.openxmlformats.org/drawingml/2006/main"/>
-          <a:ln xmlns:a="http://schemas.openxmlformats.org/drawingml/2006/main" w="0">
-            <a:noFill/>
-          </a:ln>
-        </p:spPr>
-        <p:txBody>
-          <a:bodyPr xmlns:a="http://schemas.openxmlformats.org/drawingml/2006/main" wrap="square" lIns="0" tIns="0" rIns="0" bIns="0" anchor="t"/>
-          <a:lstStyle xmlns:a="http://schemas.openxmlformats.org/drawingml/2006/main"/>
-          <a:p xmlns:a="http://schemas.openxmlformats.org/drawingml/2006/main">
-            <a:r>
-              <a:rPr lang="en-US" sz="1200" b="1">
-                <a:solidFill>
-                  <a:srgbClr val="0B8EA3"/>
-                </a:solidFill>
-                <a:latin typeface="Arial"/>
-                <a:ea typeface="Arial"/>
-              </a:rPr>
-              <a:t>THE IMAGE IS EVIDENCE, NOT FILL</a:t>
-            </a:r>
-            <a:endParaRPr lang="en-US"/>
-          </a:p>
-        </p:txBody>
-      </p:sp>
-      <p:sp>
-        <p:nvSpPr>
-          <p:cNvPr id="8" name="source"/>
-          <p:cNvSpPr txBox="1"/>
-          <p:nvPr/>
-        </p:nvSpPr>
-        <p:spPr>
-          <a:xfrm xmlns:a="http://schemas.openxmlformats.org/drawingml/2006/main">
-            <a:off x="914400" y="7829550"/>
-            <a:ext cx="10953750" cy="209550"/>
-          </a:xfrm>
-          <a:prstGeom xmlns:a="http://schemas.openxmlformats.org/drawingml/2006/main" prst="rect">
-            <a:avLst/>
-          </a:prstGeom>
-          <a:noFill xmlns:a="http://schemas.openxmlformats.org/drawingml/2006/main"/>
-          <a:ln xmlns:a="http://schemas.openxmlformats.org/drawingml/2006/main" w="0">
-            <a:noFill/>
-          </a:ln>
-        </p:spPr>
-        <p:txBody>
-          <a:bodyPr xmlns:a="http://schemas.openxmlformats.org/drawingml/2006/main" wrap="square" lIns="0" tIns="0" rIns="0" bIns="0" anchor="t"/>
-          <a:lstStyle xmlns:a="http://schemas.openxmlformats.org/drawingml/2006/main"/>
-          <a:p xmlns:a="http://schemas.openxmlformats.org/drawingml/2006/main">
-            <a:r>
-              <a:rPr lang="en-US" sz="1050">
-                <a:solidFill>
-                  <a:srgbClr val="8C9B9D"/>
-                </a:solidFill>
-                <a:latin typeface="Arial"/>
-                <a:ea typeface="Arial"/>
-              </a:rPr>
-              <a:t>OfficeKit original clean-room visual field · fictional content</a:t>
-            </a:r>
-            <a:endParaRPr lang="en-US"/>
-          </a:p>
-        </p:txBody>
-      </p:sp>
-      <p:sp>
-        <p:nvSpPr>
-          <p:cNvPr id="9" name="page-number"/>
-          <p:cNvSpPr txBox="1"/>
-          <p:nvPr/>
-        </p:nvSpPr>
-        <p:spPr>
-          <a:xfrm xmlns:a="http://schemas.openxmlformats.org/drawingml/2006/main">
-            <a:off x="13335000" y="7829550"/>
-            <a:ext cx="952500" cy="209550"/>
-          </a:xfrm>
-          <a:prstGeom xmlns:a="http://schemas.openxmlformats.org/drawingml/2006/main" prst="rect">
-            <a:avLst/>
-          </a:prstGeom>
-          <a:noFill xmlns:a="http://schemas.openxmlformats.org/drawingml/2006/main"/>
-          <a:ln xmlns:a="http://schemas.openxmlformats.org/drawingml/2006/main" w="0">
-            <a:noFill/>
-          </a:ln>
-        </p:spPr>
-        <p:txBody>
-          <a:bodyPr xmlns:a="http://schemas.openxmlformats.org/drawingml/2006/main" wrap="square" lIns="0" tIns="0" rIns="0" bIns="0" anchor="t"/>
-          <a:lstStyle xmlns:a="http://schemas.openxmlformats.org/drawingml/2006/main"/>
-          <a:p xmlns:a="http://schemas.openxmlformats.org/drawingml/2006/main">
-            <a:pPr algn="r"/>
-            <a:r>
-              <a:rPr lang="en-US" sz="1050">
-                <a:solidFill>
-                  <a:srgbClr val="8C9B9D"/>
-                </a:solidFill>
-                <a:latin typeface="Arial"/>
-                <a:ea typeface="Arial"/>
-              </a:rPr>
-              <a:t>5 / 6</a:t>
-            </a:r>
-            <a:endParaRPr lang="en-US"/>
-          </a:p>
-        </p:txBody>
-      </p:sp>
-    </p:spTree>
-  </p:cSld>
-  <p:clrMapOvr>
-    <a:masterClrMapping xmlns:a="http://schemas.openxmlformats.org/drawingml/2006/main"/>
-  </p:clrMapOvr>
-</p:sld>
-</file>
-
-<file path=ppt/slides/slide6.xml><?xml version="1.0" encoding="utf-8"?>
-<p:sld xmlns:p="http://schemas.openxmlformats.org/presentationml/2006/main">
-  <p:cSld name="Decision close">
-    <p:bg>
-      <p:bgPr>
-        <a:blipFill xmlns:a="http://schemas.openxmlformats.org/drawingml/2006/main">
-          <a:blip xmlns:r="http://schemas.openxmlformats.org/officeDocument/2006/relationships" r:embed="rIdOfficeKitImage7790b68b5d8fcd92_1"/>
-          <a:stretch>
-            <a:fillRect/>
-          </a:stretch>
-        </a:blipFill>
-      </p:bgPr>
-    </p:bg>
-    <p:spTree>
-      <p:nvGrpSpPr>
-        <p:cNvPr id="1" name=""/>
-        <p:cNvGrpSpPr/>
-        <p:nvPr/>
-      </p:nvGrpSpPr>
-      <p:grpSpPr>
-        <a:xfrm xmlns:a="http://schemas.openxmlformats.org/drawingml/2006/main">
-          <a:off x="0" y="0"/>
-          <a:ext cx="0" cy="0"/>
-          <a:chOff x="0" y="0"/>
-          <a:chExt cx="0" cy="0"/>
-        </a:xfrm>
-      </p:grpSpPr>
-      <p:sp>
-        <p:nvSpPr>
           <p:cNvPr id="2" name="close-paper-scrim"/>
           <p:cNvSpPr/>
           <p:nvPr/>

</xml_diff>

<commit_message>
feat(templates): diversify image-led promotion references
</commit_message>
<xml_diff>
--- a/skills/presentation-template-library/skills/artifact-template-aqua-impact-story/assets/reference.pptx
+++ b/skills/presentation-template-library/skills/artifact-template-aqua-impact-story/assets/reference.pptx
@@ -906,7 +906,7 @@
         </p:nvPicPr>
         <p:blipFill>
           <a:blip xmlns:r="http://schemas.openxmlformats.org/officeDocument/2006/relationships" xmlns:a="http://schemas.openxmlformats.org/drawingml/2006/main" r:embed="rIdOfficeKitImagee930dcb9c6b95953_1"/>
-          <a:srcRect xmlns:a="http://schemas.openxmlformats.org/drawingml/2006/main" l="0" t="31920" r="0" b="31920"/>
+          <a:srcRect xmlns:a="http://schemas.openxmlformats.org/drawingml/2006/main" l="0" t="37411" r="0" b="37411"/>
           <a:stretch xmlns:a="http://schemas.openxmlformats.org/drawingml/2006/main">
             <a:fillRect/>
           </a:stretch>
@@ -914,22 +914,80 @@
         <p:spPr>
           <a:xfrm xmlns:a="http://schemas.openxmlformats.org/drawingml/2006/main">
             <a:off x="9525000" y="3143250"/>
-            <a:ext cx="4000500" cy="2571750"/>
+            <a:ext cx="4000500" cy="1790700"/>
           </a:xfrm>
           <a:prstGeom xmlns:a="http://schemas.openxmlformats.org/drawingml/2006/main" prst="rect">
             <a:avLst/>
           </a:prstGeom>
         </p:spPr>
       </p:pic>
-      <p:sp>
-        <p:nvSpPr>
-          <p:cNvPr id="12" name="promotion-image-rule"/>
+      <p:pic>
+        <p:nvPicPr>
+          <p:cNvPr id="12" name="promotion-detail-frame-one">
+            <a:extLst xmlns:a="http://schemas.openxmlformats.org/drawingml/2006/main">
+              <a:ext uri="{C183D7F6-B498-43B3-948B-1728B52AA6E4}">
+                <adec:decorative xmlns:adec="http://schemas.microsoft.com/office/drawing/2017/decorative" val="1"/>
+              </a:ext>
+            </a:extLst>
+          </p:cNvPr>
+          <p:cNvPicPr/>
+          <p:nvPr/>
+        </p:nvPicPr>
+        <p:blipFill>
+          <a:blip xmlns:r="http://schemas.openxmlformats.org/officeDocument/2006/relationships" xmlns:a="http://schemas.openxmlformats.org/drawingml/2006/main" r:embed="rIdOfficeKitImage5e425a7c66b022d4_1"/>
+          <a:srcRect xmlns:a="http://schemas.openxmlformats.org/drawingml/2006/main" l="0" t="34406" r="0" b="34406"/>
+          <a:stretch xmlns:a="http://schemas.openxmlformats.org/drawingml/2006/main">
+            <a:fillRect/>
+          </a:stretch>
+        </p:blipFill>
+        <p:spPr>
+          <a:xfrm xmlns:a="http://schemas.openxmlformats.org/drawingml/2006/main">
+            <a:off x="9525000" y="5162550"/>
+            <a:ext cx="1924050" cy="1066800"/>
+          </a:xfrm>
+          <a:prstGeom xmlns:a="http://schemas.openxmlformats.org/drawingml/2006/main" prst="rect">
+            <a:avLst/>
+          </a:prstGeom>
+        </p:spPr>
+      </p:pic>
+      <p:pic>
+        <p:nvPicPr>
+          <p:cNvPr id="13" name="promotion-detail-frame-two">
+            <a:extLst xmlns:a="http://schemas.openxmlformats.org/drawingml/2006/main">
+              <a:ext uri="{C183D7F6-B498-43B3-948B-1728B52AA6E4}">
+                <adec:decorative xmlns:adec="http://schemas.microsoft.com/office/drawing/2017/decorative" val="1"/>
+              </a:ext>
+            </a:extLst>
+          </p:cNvPr>
+          <p:cNvPicPr/>
+          <p:nvPr/>
+        </p:nvPicPr>
+        <p:blipFill>
+          <a:blip xmlns:r="http://schemas.openxmlformats.org/officeDocument/2006/relationships" xmlns:a="http://schemas.openxmlformats.org/drawingml/2006/main" r:embed="rIdOfficeKitImage84ff976f39aab728_1"/>
+          <a:srcRect xmlns:a="http://schemas.openxmlformats.org/drawingml/2006/main" l="0" t="34406" r="0" b="34406"/>
+          <a:stretch xmlns:a="http://schemas.openxmlformats.org/drawingml/2006/main">
+            <a:fillRect/>
+          </a:stretch>
+        </p:blipFill>
+        <p:spPr>
+          <a:xfrm xmlns:a="http://schemas.openxmlformats.org/drawingml/2006/main">
+            <a:off x="11601450" y="5162550"/>
+            <a:ext cx="1924050" cy="1066800"/>
+          </a:xfrm>
+          <a:prstGeom xmlns:a="http://schemas.openxmlformats.org/drawingml/2006/main" prst="rect">
+            <a:avLst/>
+          </a:prstGeom>
+        </p:spPr>
+      </p:pic>
+      <p:sp>
+        <p:nvSpPr>
+          <p:cNvPr id="14" name="promotion-image-rule"/>
           <p:cNvSpPr/>
           <p:nvPr/>
         </p:nvSpPr>
         <p:spPr>
           <a:xfrm xmlns:a="http://schemas.openxmlformats.org/drawingml/2006/main">
-            <a:off x="9525000" y="5905500"/>
+            <a:off x="9525000" y="6438900"/>
             <a:ext cx="4000500" cy="0"/>
           </a:xfrm>
           <a:prstGeom xmlns:a="http://schemas.openxmlformats.org/drawingml/2006/main" prst="line">
@@ -957,13 +1015,13 @@
       </p:sp>
       <p:sp>
         <p:nvSpPr>
-          <p:cNvPr id="13" name="promotion-image-label"/>
-          <p:cNvSpPr txBox="1"/>
-          <p:nvPr/>
-        </p:nvSpPr>
-        <p:spPr>
-          <a:xfrm xmlns:a="http://schemas.openxmlformats.org/drawingml/2006/main">
-            <a:off x="9525000" y="6153150"/>
+          <p:cNvPr id="15" name="promotion-image-label"/>
+          <p:cNvSpPr txBox="1"/>
+          <p:nvPr/>
+        </p:nvSpPr>
+        <p:spPr>
+          <a:xfrm xmlns:a="http://schemas.openxmlformats.org/drawingml/2006/main">
+            <a:off x="9525000" y="6667500"/>
             <a:ext cx="4000500" cy="247650"/>
           </a:xfrm>
           <a:prstGeom xmlns:a="http://schemas.openxmlformats.org/drawingml/2006/main" prst="rect">
@@ -994,7 +1052,7 @@
       </p:sp>
       <p:sp>
         <p:nvSpPr>
-          <p:cNvPr id="14" name="source"/>
+          <p:cNvPr id="16" name="source"/>
           <p:cNvSpPr txBox="1"/>
           <p:nvPr/>
         </p:nvSpPr>
@@ -1031,7 +1089,7 @@
       </p:sp>
       <p:sp>
         <p:nvSpPr>
-          <p:cNvPr id="15" name="page-number"/>
+          <p:cNvPr id="17" name="page-number"/>
           <p:cNvSpPr txBox="1"/>
           <p:nvPr/>
         </p:nvSpPr>
@@ -1081,7 +1139,7 @@
     <p:bg>
       <p:bgPr>
         <a:blipFill xmlns:a="http://schemas.openxmlformats.org/drawingml/2006/main">
-          <a:blip xmlns:r="http://schemas.openxmlformats.org/officeDocument/2006/relationships" r:embed="rIdOfficeKitImage5e425a7c66b022d4_1"/>
+          <a:blip xmlns:r="http://schemas.openxmlformats.org/officeDocument/2006/relationships" r:embed="rIdOfficeKitImage20fc6993425855c3_1"/>
           <a:stretch>
             <a:fillRect/>
           </a:stretch>
@@ -2429,8 +2487,8 @@
           <p:nvPr/>
         </p:nvPicPr>
         <p:blipFill>
-          <a:blip xmlns:r="http://schemas.openxmlformats.org/officeDocument/2006/relationships" xmlns:a="http://schemas.openxmlformats.org/drawingml/2006/main" r:embed="rIdOfficeKitImage84ff976f39aab728_1"/>
-          <a:srcRect xmlns:a="http://schemas.openxmlformats.org/drawingml/2006/main" l="0" t="31971" r="0" b="31971"/>
+          <a:blip xmlns:r="http://schemas.openxmlformats.org/officeDocument/2006/relationships" xmlns:a="http://schemas.openxmlformats.org/drawingml/2006/main" r:embed="rIdOfficeKitImagee977612ad933c986_1"/>
+          <a:srcRect xmlns:a="http://schemas.openxmlformats.org/drawingml/2006/main" l="0" t="31957" r="0" b="31957"/>
           <a:stretch xmlns:a="http://schemas.openxmlformats.org/drawingml/2006/main">
             <a:fillRect/>
           </a:stretch>
@@ -2458,8 +2516,8 @@
           <p:nvPr/>
         </p:nvPicPr>
         <p:blipFill>
-          <a:blip xmlns:r="http://schemas.openxmlformats.org/officeDocument/2006/relationships" xmlns:a="http://schemas.openxmlformats.org/drawingml/2006/main" r:embed="rIdOfficeKitImage20fc6993425855c3_1"/>
-          <a:srcRect xmlns:a="http://schemas.openxmlformats.org/drawingml/2006/main" l="0" t="32333" r="0" b="32333"/>
+          <a:blip xmlns:r="http://schemas.openxmlformats.org/officeDocument/2006/relationships" xmlns:a="http://schemas.openxmlformats.org/drawingml/2006/main" r:embed="rIdOfficeKitImaged96cedd8678b85ac_1"/>
+          <a:srcRect xmlns:a="http://schemas.openxmlformats.org/drawingml/2006/main" l="0" t="32347" r="0" b="32347"/>
           <a:stretch xmlns:a="http://schemas.openxmlformats.org/drawingml/2006/main">
             <a:fillRect/>
           </a:stretch>
@@ -2487,8 +2545,8 @@
           <p:nvPr/>
         </p:nvPicPr>
         <p:blipFill>
-          <a:blip xmlns:r="http://schemas.openxmlformats.org/officeDocument/2006/relationships" xmlns:a="http://schemas.openxmlformats.org/drawingml/2006/main" r:embed="rIdOfficeKitImagee977612ad933c986_1"/>
-          <a:srcRect xmlns:a="http://schemas.openxmlformats.org/drawingml/2006/main" l="0" t="32333" r="0" b="32333"/>
+          <a:blip xmlns:r="http://schemas.openxmlformats.org/officeDocument/2006/relationships" xmlns:a="http://schemas.openxmlformats.org/drawingml/2006/main" r:embed="rIdOfficeKitImage35d943dc999c7d05_1"/>
+          <a:srcRect xmlns:a="http://schemas.openxmlformats.org/drawingml/2006/main" l="0" t="32347" r="0" b="32347"/>
           <a:stretch xmlns:a="http://schemas.openxmlformats.org/drawingml/2006/main">
             <a:fillRect/>
           </a:stretch>
@@ -2516,14 +2574,14 @@
           <p:nvPr/>
         </p:nvPicPr>
         <p:blipFill>
-          <a:blip xmlns:r="http://schemas.openxmlformats.org/officeDocument/2006/relationships" xmlns:a="http://schemas.openxmlformats.org/drawingml/2006/main" r:embed="rIdOfficeKitImaged96cedd8678b85ac_1"/>
+          <a:blip xmlns:r="http://schemas.openxmlformats.org/officeDocument/2006/relationships" xmlns:a="http://schemas.openxmlformats.org/drawingml/2006/main" r:embed="rIdOfficeKitImagedf986129197cef3b_1"/>
           <a:srcRect xmlns:a="http://schemas.openxmlformats.org/drawingml/2006/main" l="0" t="32347" r="0" b="32347"/>
           <a:stretch xmlns:a="http://schemas.openxmlformats.org/drawingml/2006/main">
             <a:fillRect/>
           </a:stretch>
         </p:blipFill>
         <p:spPr>
-          <a:xfrm xmlns:a="http://schemas.openxmlformats.org/drawingml/2006/main">
+          <a:xfrm xmlns:a="http://schemas.openxmlformats.org/drawingml/2006/main" flipH="1">
             <a:off x="4895850" y="4457700"/>
             <a:ext cx="1790700" cy="1123950"/>
           </a:xfrm>
@@ -2545,8 +2603,8 @@
           <p:nvPr/>
         </p:nvPicPr>
         <p:blipFill>
-          <a:blip xmlns:r="http://schemas.openxmlformats.org/officeDocument/2006/relationships" xmlns:a="http://schemas.openxmlformats.org/drawingml/2006/main" r:embed="rIdOfficeKitImage35d943dc999c7d05_1"/>
-          <a:srcRect xmlns:a="http://schemas.openxmlformats.org/drawingml/2006/main" l="0" t="32347" r="0" b="32347"/>
+          <a:blip xmlns:r="http://schemas.openxmlformats.org/officeDocument/2006/relationships" xmlns:a="http://schemas.openxmlformats.org/drawingml/2006/main" r:embed="rIdOfficeKitImagecb4e39f1eccfa545_1"/>
+          <a:srcRect xmlns:a="http://schemas.openxmlformats.org/drawingml/2006/main" l="0" t="32333" r="0" b="32333"/>
           <a:stretch xmlns:a="http://schemas.openxmlformats.org/drawingml/2006/main">
             <a:fillRect/>
           </a:stretch>
@@ -2784,359 +2842,10 @@
 <file path=ppt/slides/slide5.xml><?xml version="1.0" encoding="utf-8"?>
 <p:sld xmlns:p="http://schemas.openxmlformats.org/presentationml/2006/main">
   <p:cSld name="Visual carrier">
-    <p:spTree>
-      <p:nvGrpSpPr>
-        <p:cNvPr id="1" name=""/>
-        <p:cNvGrpSpPr/>
-        <p:nvPr/>
-      </p:nvGrpSpPr>
-      <p:grpSpPr>
-        <a:xfrm xmlns:a="http://schemas.openxmlformats.org/drawingml/2006/main">
-          <a:off x="0" y="0"/>
-          <a:ext cx="0" cy="0"/>
-          <a:chOff x="0" y="0"/>
-          <a:chExt cx="0" cy="0"/>
-        </a:xfrm>
-      </p:grpSpPr>
-      <p:pic>
-        <p:nvPicPr>
-          <p:cNvPr id="2" name="visual-visual-field">
-            <a:extLst xmlns:a="http://schemas.openxmlformats.org/drawingml/2006/main">
-              <a:ext uri="{C183D7F6-B498-43B3-948B-1728B52AA6E4}">
-                <adec:decorative xmlns:adec="http://schemas.microsoft.com/office/drawing/2017/decorative" val="1"/>
-              </a:ext>
-            </a:extLst>
-          </p:cNvPr>
-          <p:cNvPicPr/>
-          <p:nvPr/>
-        </p:nvPicPr>
-        <p:blipFill>
-          <a:blip xmlns:r="http://schemas.openxmlformats.org/officeDocument/2006/relationships" xmlns:a="http://schemas.openxmlformats.org/drawingml/2006/main" r:embed="rIdOfficeKitImagedf986129197cef3b_1"/>
-          <a:srcRect xmlns:a="http://schemas.openxmlformats.org/drawingml/2006/main" l="0" t="34180" r="0" b="34180"/>
-          <a:stretch xmlns:a="http://schemas.openxmlformats.org/drawingml/2006/main">
-            <a:fillRect/>
-          </a:stretch>
-        </p:blipFill>
-        <p:spPr>
-          <a:xfrm xmlns:a="http://schemas.openxmlformats.org/drawingml/2006/main" flipH="1">
-            <a:off x="0" y="0"/>
-            <a:ext cx="15240000" cy="8572500"/>
-          </a:xfrm>
-          <a:prstGeom xmlns:a="http://schemas.openxmlformats.org/drawingml/2006/main" prst="rect">
-            <a:avLst/>
-          </a:prstGeom>
-        </p:spPr>
-      </p:pic>
-      <p:sp>
-        <p:nvSpPr>
-          <p:cNvPr id="3" name="visual-scrim"/>
-          <p:cNvSpPr/>
-          <p:nvPr/>
-        </p:nvSpPr>
-        <p:spPr>
-          <a:xfrm xmlns:a="http://schemas.openxmlformats.org/drawingml/2006/main">
-            <a:off x="0" y="0"/>
-            <a:ext cx="6858000" cy="8572500"/>
-          </a:xfrm>
-          <a:prstGeom xmlns:a="http://schemas.openxmlformats.org/drawingml/2006/main" prst="rect">
-            <a:avLst/>
-          </a:prstGeom>
-          <a:solidFill xmlns:a="http://schemas.openxmlformats.org/drawingml/2006/main">
-            <a:srgbClr val="F3EFE4">
-              <a:alpha val="88000"/>
-            </a:srgbClr>
-          </a:solidFill>
-          <a:ln xmlns:a="http://schemas.openxmlformats.org/drawingml/2006/main" w="0">
-            <a:solidFill>
-              <a:srgbClr val="F3EFE4"/>
-            </a:solidFill>
-            <a:prstDash val="solid"/>
-          </a:ln>
-        </p:spPr>
-        <p:txBody>
-          <a:bodyPr xmlns:a="http://schemas.openxmlformats.org/drawingml/2006/main" wrap="square" lIns="0" tIns="0" rIns="0" bIns="0" anchor="t"/>
-          <a:lstStyle xmlns:a="http://schemas.openxmlformats.org/drawingml/2006/main"/>
-          <a:p xmlns:a="http://schemas.openxmlformats.org/drawingml/2006/main">
-            <a:r>
-              <a:rPr lang="en-US"/>
-              <a:t/>
-            </a:r>
-            <a:endParaRPr lang="en-US"/>
-          </a:p>
-        </p:txBody>
-      </p:sp>
-      <p:sp>
-        <p:nvSpPr>
-          <p:cNvPr id="4" name="visual-eyebrow"/>
-          <p:cNvSpPr txBox="1"/>
-          <p:nvPr/>
-        </p:nvSpPr>
-        <p:spPr>
-          <a:xfrm xmlns:a="http://schemas.openxmlformats.org/drawingml/2006/main">
-            <a:off x="914400" y="895350"/>
-            <a:ext cx="6667500" cy="228600"/>
-          </a:xfrm>
-          <a:prstGeom xmlns:a="http://schemas.openxmlformats.org/drawingml/2006/main" prst="rect">
-            <a:avLst/>
-          </a:prstGeom>
-          <a:noFill xmlns:a="http://schemas.openxmlformats.org/drawingml/2006/main"/>
-          <a:ln xmlns:a="http://schemas.openxmlformats.org/drawingml/2006/main" w="0">
-            <a:noFill/>
-          </a:ln>
-        </p:spPr>
-        <p:txBody>
-          <a:bodyPr xmlns:a="http://schemas.openxmlformats.org/drawingml/2006/main" wrap="square" lIns="0" tIns="0" rIns="0" bIns="0" anchor="t"/>
-          <a:lstStyle xmlns:a="http://schemas.openxmlformats.org/drawingml/2006/main"/>
-          <a:p xmlns:a="http://schemas.openxmlformats.org/drawingml/2006/main">
-            <a:r>
-              <a:rPr lang="en-US" sz="1200" b="1">
-                <a:solidFill>
-                  <a:srgbClr val="0B8EA3"/>
-                </a:solidFill>
-                <a:latin typeface="Arial"/>
-                <a:ea typeface="Arial"/>
-              </a:rPr>
-              <a:t>AQUA IMPACT STORY · VISUAL CARRIER</a:t>
-            </a:r>
-            <a:endParaRPr lang="en-US"/>
-          </a:p>
-        </p:txBody>
-      </p:sp>
-      <p:sp>
-        <p:nvSpPr>
-          <p:cNvPr id="5" name="visual-title"/>
-          <p:cNvSpPr txBox="1"/>
-          <p:nvPr/>
-        </p:nvSpPr>
-        <p:spPr>
-          <a:xfrm xmlns:a="http://schemas.openxmlformats.org/drawingml/2006/main">
-            <a:off x="914400" y="1638300"/>
-            <a:ext cx="5334000" cy="1143000"/>
-          </a:xfrm>
-          <a:prstGeom xmlns:a="http://schemas.openxmlformats.org/drawingml/2006/main" prst="rect">
-            <a:avLst/>
-          </a:prstGeom>
-          <a:noFill xmlns:a="http://schemas.openxmlformats.org/drawingml/2006/main"/>
-          <a:ln xmlns:a="http://schemas.openxmlformats.org/drawingml/2006/main" w="0">
-            <a:noFill/>
-          </a:ln>
-        </p:spPr>
-        <p:txBody>
-          <a:bodyPr xmlns:a="http://schemas.openxmlformats.org/drawingml/2006/main" wrap="square" lIns="0" tIns="0" rIns="0" bIns="0" anchor="t"/>
-          <a:lstStyle xmlns:a="http://schemas.openxmlformats.org/drawingml/2006/main"/>
-          <a:p xmlns:a="http://schemas.openxmlformats.org/drawingml/2006/main">
-            <a:r>
-              <a:rPr lang="en-US" sz="3300" b="1">
-                <a:solidFill>
-                  <a:srgbClr val="1D4150"/>
-                </a:solidFill>
-                <a:latin typeface="Arial"/>
-                <a:ea typeface="Arial"/>
-              </a:rPr>
-              <a:t>Let the subject do the work</a:t>
-            </a:r>
-            <a:endParaRPr lang="en-US"/>
-          </a:p>
-        </p:txBody>
-      </p:sp>
-      <p:sp>
-        <p:nvSpPr>
-          <p:cNvPr id="6" name="visual-body"/>
-          <p:cNvSpPr txBox="1"/>
-          <p:nvPr/>
-        </p:nvSpPr>
-        <p:spPr>
-          <a:xfrm xmlns:a="http://schemas.openxmlformats.org/drawingml/2006/main">
-            <a:off x="914400" y="3219450"/>
-            <a:ext cx="4762500" cy="685800"/>
-          </a:xfrm>
-          <a:prstGeom xmlns:a="http://schemas.openxmlformats.org/drawingml/2006/main" prst="rect">
-            <a:avLst/>
-          </a:prstGeom>
-          <a:noFill xmlns:a="http://schemas.openxmlformats.org/drawingml/2006/main"/>
-          <a:ln xmlns:a="http://schemas.openxmlformats.org/drawingml/2006/main" w="0">
-            <a:noFill/>
-          </a:ln>
-        </p:spPr>
-        <p:txBody>
-          <a:bodyPr xmlns:a="http://schemas.openxmlformats.org/drawingml/2006/main" wrap="square" lIns="0" tIns="0" rIns="0" bIns="0" anchor="t"/>
-          <a:lstStyle xmlns:a="http://schemas.openxmlformats.org/drawingml/2006/main"/>
-          <a:p xmlns:a="http://schemas.openxmlformats.org/drawingml/2006/main">
-            <a:r>
-              <a:rPr lang="en-US" sz="1800">
-                <a:solidFill>
-                  <a:srgbClr val="1D4150"/>
-                </a:solidFill>
-                <a:latin typeface="Arial"/>
-                <a:ea typeface="Arial"/>
-              </a:rPr>
-              <a:t>A strong crop gives the proposition a place to live.</a:t>
-            </a:r>
-            <a:endParaRPr lang="en-US"/>
-          </a:p>
-        </p:txBody>
-      </p:sp>
-      <p:sp>
-        <p:nvSpPr>
-          <p:cNvPr id="7" name="visual-rule"/>
-          <p:cNvSpPr/>
-          <p:nvPr/>
-        </p:nvSpPr>
-        <p:spPr>
-          <a:xfrm xmlns:a="http://schemas.openxmlformats.org/drawingml/2006/main">
-            <a:off x="914400" y="4476750"/>
-            <a:ext cx="4419600" cy="0"/>
-          </a:xfrm>
-          <a:prstGeom xmlns:a="http://schemas.openxmlformats.org/drawingml/2006/main" prst="line">
-            <a:avLst/>
-          </a:prstGeom>
-          <a:noFill xmlns:a="http://schemas.openxmlformats.org/drawingml/2006/main"/>
-          <a:ln xmlns:a="http://schemas.openxmlformats.org/drawingml/2006/main" w="38100">
-            <a:solidFill>
-              <a:srgbClr val="0B8EA3"/>
-            </a:solidFill>
-            <a:prstDash val="solid"/>
-          </a:ln>
-        </p:spPr>
-        <p:txBody>
-          <a:bodyPr xmlns:a="http://schemas.openxmlformats.org/drawingml/2006/main" wrap="square" lIns="0" tIns="0" rIns="0" bIns="0" anchor="t"/>
-          <a:lstStyle xmlns:a="http://schemas.openxmlformats.org/drawingml/2006/main"/>
-          <a:p xmlns:a="http://schemas.openxmlformats.org/drawingml/2006/main">
-            <a:r>
-              <a:rPr lang="en-US"/>
-              <a:t/>
-            </a:r>
-            <a:endParaRPr lang="en-US"/>
-          </a:p>
-        </p:txBody>
-      </p:sp>
-      <p:sp>
-        <p:nvSpPr>
-          <p:cNvPr id="8" name="visual-label"/>
-          <p:cNvSpPr txBox="1"/>
-          <p:nvPr/>
-        </p:nvSpPr>
-        <p:spPr>
-          <a:xfrm xmlns:a="http://schemas.openxmlformats.org/drawingml/2006/main">
-            <a:off x="914400" y="4819650"/>
-            <a:ext cx="4953000" cy="228600"/>
-          </a:xfrm>
-          <a:prstGeom xmlns:a="http://schemas.openxmlformats.org/drawingml/2006/main" prst="rect">
-            <a:avLst/>
-          </a:prstGeom>
-          <a:noFill xmlns:a="http://schemas.openxmlformats.org/drawingml/2006/main"/>
-          <a:ln xmlns:a="http://schemas.openxmlformats.org/drawingml/2006/main" w="0">
-            <a:noFill/>
-          </a:ln>
-        </p:spPr>
-        <p:txBody>
-          <a:bodyPr xmlns:a="http://schemas.openxmlformats.org/drawingml/2006/main" wrap="square" lIns="0" tIns="0" rIns="0" bIns="0" anchor="t"/>
-          <a:lstStyle xmlns:a="http://schemas.openxmlformats.org/drawingml/2006/main"/>
-          <a:p xmlns:a="http://schemas.openxmlformats.org/drawingml/2006/main">
-            <a:r>
-              <a:rPr lang="en-US" sz="1200" b="1">
-                <a:solidFill>
-                  <a:srgbClr val="0B8EA3"/>
-                </a:solidFill>
-                <a:latin typeface="Arial"/>
-                <a:ea typeface="Arial"/>
-              </a:rPr>
-              <a:t>THE IMAGE IS EVIDENCE, NOT FILL</a:t>
-            </a:r>
-            <a:endParaRPr lang="en-US"/>
-          </a:p>
-        </p:txBody>
-      </p:sp>
-      <p:sp>
-        <p:nvSpPr>
-          <p:cNvPr id="9" name="source"/>
-          <p:cNvSpPr txBox="1"/>
-          <p:nvPr/>
-        </p:nvSpPr>
-        <p:spPr>
-          <a:xfrm xmlns:a="http://schemas.openxmlformats.org/drawingml/2006/main">
-            <a:off x="914400" y="7829550"/>
-            <a:ext cx="10953750" cy="209550"/>
-          </a:xfrm>
-          <a:prstGeom xmlns:a="http://schemas.openxmlformats.org/drawingml/2006/main" prst="rect">
-            <a:avLst/>
-          </a:prstGeom>
-          <a:noFill xmlns:a="http://schemas.openxmlformats.org/drawingml/2006/main"/>
-          <a:ln xmlns:a="http://schemas.openxmlformats.org/drawingml/2006/main" w="0">
-            <a:noFill/>
-          </a:ln>
-        </p:spPr>
-        <p:txBody>
-          <a:bodyPr xmlns:a="http://schemas.openxmlformats.org/drawingml/2006/main" wrap="square" lIns="0" tIns="0" rIns="0" bIns="0" anchor="t"/>
-          <a:lstStyle xmlns:a="http://schemas.openxmlformats.org/drawingml/2006/main"/>
-          <a:p xmlns:a="http://schemas.openxmlformats.org/drawingml/2006/main">
-            <a:r>
-              <a:rPr lang="en-US" sz="1050">
-                <a:solidFill>
-                  <a:srgbClr val="8C9B9D"/>
-                </a:solidFill>
-                <a:latin typeface="Arial"/>
-                <a:ea typeface="Arial"/>
-              </a:rPr>
-              <a:t>OfficeKit original clean-room visual field · fictional content</a:t>
-            </a:r>
-            <a:endParaRPr lang="en-US"/>
-          </a:p>
-        </p:txBody>
-      </p:sp>
-      <p:sp>
-        <p:nvSpPr>
-          <p:cNvPr id="10" name="page-number"/>
-          <p:cNvSpPr txBox="1"/>
-          <p:nvPr/>
-        </p:nvSpPr>
-        <p:spPr>
-          <a:xfrm xmlns:a="http://schemas.openxmlformats.org/drawingml/2006/main">
-            <a:off x="13335000" y="7829550"/>
-            <a:ext cx="952500" cy="209550"/>
-          </a:xfrm>
-          <a:prstGeom xmlns:a="http://schemas.openxmlformats.org/drawingml/2006/main" prst="rect">
-            <a:avLst/>
-          </a:prstGeom>
-          <a:noFill xmlns:a="http://schemas.openxmlformats.org/drawingml/2006/main"/>
-          <a:ln xmlns:a="http://schemas.openxmlformats.org/drawingml/2006/main" w="0">
-            <a:noFill/>
-          </a:ln>
-        </p:spPr>
-        <p:txBody>
-          <a:bodyPr xmlns:a="http://schemas.openxmlformats.org/drawingml/2006/main" wrap="square" lIns="0" tIns="0" rIns="0" bIns="0" anchor="t"/>
-          <a:lstStyle xmlns:a="http://schemas.openxmlformats.org/drawingml/2006/main"/>
-          <a:p xmlns:a="http://schemas.openxmlformats.org/drawingml/2006/main">
-            <a:pPr algn="r"/>
-            <a:r>
-              <a:rPr lang="en-US" sz="1050">
-                <a:solidFill>
-                  <a:srgbClr val="8C9B9D"/>
-                </a:solidFill>
-                <a:latin typeface="Arial"/>
-                <a:ea typeface="Arial"/>
-              </a:rPr>
-              <a:t>5 / 6</a:t>
-            </a:r>
-            <a:endParaRPr lang="en-US"/>
-          </a:p>
-        </p:txBody>
-      </p:sp>
-    </p:spTree>
-  </p:cSld>
-  <p:clrMapOvr>
-    <a:masterClrMapping xmlns:a="http://schemas.openxmlformats.org/drawingml/2006/main"/>
-  </p:clrMapOvr>
-</p:sld>
-</file>
-
-<file path=ppt/slides/slide6.xml><?xml version="1.0" encoding="utf-8"?>
-<p:sld xmlns:p="http://schemas.openxmlformats.org/presentationml/2006/main">
-  <p:cSld name="Decision close">
     <p:bg>
       <p:bgPr>
         <a:blipFill xmlns:a="http://schemas.openxmlformats.org/drawingml/2006/main">
-          <a:blip xmlns:r="http://schemas.openxmlformats.org/officeDocument/2006/relationships" r:embed="rIdOfficeKitImagecb4e39f1eccfa545_1"/>
+          <a:blip xmlns:r="http://schemas.openxmlformats.org/officeDocument/2006/relationships" r:embed="rIdOfficeKitImage06e55191024fa458_1"/>
           <a:stretch>
             <a:fillRect/>
           </a:stretch>
@@ -3159,6 +2868,336 @@
       </p:grpSpPr>
       <p:sp>
         <p:nvSpPr>
+          <p:cNvPr id="2" name="visual-scrim"/>
+          <p:cNvSpPr/>
+          <p:nvPr/>
+        </p:nvSpPr>
+        <p:spPr>
+          <a:xfrm xmlns:a="http://schemas.openxmlformats.org/drawingml/2006/main">
+            <a:off x="0" y="0"/>
+            <a:ext cx="6858000" cy="8572500"/>
+          </a:xfrm>
+          <a:prstGeom xmlns:a="http://schemas.openxmlformats.org/drawingml/2006/main" prst="rect">
+            <a:avLst/>
+          </a:prstGeom>
+          <a:solidFill xmlns:a="http://schemas.openxmlformats.org/drawingml/2006/main">
+            <a:srgbClr val="F3EFE4">
+              <a:alpha val="88000"/>
+            </a:srgbClr>
+          </a:solidFill>
+          <a:ln xmlns:a="http://schemas.openxmlformats.org/drawingml/2006/main" w="0">
+            <a:solidFill>
+              <a:srgbClr val="F3EFE4"/>
+            </a:solidFill>
+            <a:prstDash val="solid"/>
+          </a:ln>
+        </p:spPr>
+        <p:txBody>
+          <a:bodyPr xmlns:a="http://schemas.openxmlformats.org/drawingml/2006/main" wrap="square" lIns="0" tIns="0" rIns="0" bIns="0" anchor="t"/>
+          <a:lstStyle xmlns:a="http://schemas.openxmlformats.org/drawingml/2006/main"/>
+          <a:p xmlns:a="http://schemas.openxmlformats.org/drawingml/2006/main">
+            <a:r>
+              <a:rPr lang="en-US"/>
+              <a:t/>
+            </a:r>
+            <a:endParaRPr lang="en-US"/>
+          </a:p>
+        </p:txBody>
+      </p:sp>
+      <p:sp>
+        <p:nvSpPr>
+          <p:cNvPr id="3" name="visual-eyebrow"/>
+          <p:cNvSpPr txBox="1"/>
+          <p:nvPr/>
+        </p:nvSpPr>
+        <p:spPr>
+          <a:xfrm xmlns:a="http://schemas.openxmlformats.org/drawingml/2006/main">
+            <a:off x="914400" y="895350"/>
+            <a:ext cx="6667500" cy="228600"/>
+          </a:xfrm>
+          <a:prstGeom xmlns:a="http://schemas.openxmlformats.org/drawingml/2006/main" prst="rect">
+            <a:avLst/>
+          </a:prstGeom>
+          <a:noFill xmlns:a="http://schemas.openxmlformats.org/drawingml/2006/main"/>
+          <a:ln xmlns:a="http://schemas.openxmlformats.org/drawingml/2006/main" w="0">
+            <a:noFill/>
+          </a:ln>
+        </p:spPr>
+        <p:txBody>
+          <a:bodyPr xmlns:a="http://schemas.openxmlformats.org/drawingml/2006/main" wrap="square" lIns="0" tIns="0" rIns="0" bIns="0" anchor="t"/>
+          <a:lstStyle xmlns:a="http://schemas.openxmlformats.org/drawingml/2006/main"/>
+          <a:p xmlns:a="http://schemas.openxmlformats.org/drawingml/2006/main">
+            <a:r>
+              <a:rPr lang="en-US" sz="1200" b="1">
+                <a:solidFill>
+                  <a:srgbClr val="0B8EA3"/>
+                </a:solidFill>
+                <a:latin typeface="Arial"/>
+                <a:ea typeface="Arial"/>
+              </a:rPr>
+              <a:t>AQUA IMPACT STORY · VISUAL CARRIER</a:t>
+            </a:r>
+            <a:endParaRPr lang="en-US"/>
+          </a:p>
+        </p:txBody>
+      </p:sp>
+      <p:sp>
+        <p:nvSpPr>
+          <p:cNvPr id="4" name="visual-title"/>
+          <p:cNvSpPr txBox="1"/>
+          <p:nvPr/>
+        </p:nvSpPr>
+        <p:spPr>
+          <a:xfrm xmlns:a="http://schemas.openxmlformats.org/drawingml/2006/main">
+            <a:off x="914400" y="1638300"/>
+            <a:ext cx="5334000" cy="1143000"/>
+          </a:xfrm>
+          <a:prstGeom xmlns:a="http://schemas.openxmlformats.org/drawingml/2006/main" prst="rect">
+            <a:avLst/>
+          </a:prstGeom>
+          <a:noFill xmlns:a="http://schemas.openxmlformats.org/drawingml/2006/main"/>
+          <a:ln xmlns:a="http://schemas.openxmlformats.org/drawingml/2006/main" w="0">
+            <a:noFill/>
+          </a:ln>
+        </p:spPr>
+        <p:txBody>
+          <a:bodyPr xmlns:a="http://schemas.openxmlformats.org/drawingml/2006/main" wrap="square" lIns="0" tIns="0" rIns="0" bIns="0" anchor="t"/>
+          <a:lstStyle xmlns:a="http://schemas.openxmlformats.org/drawingml/2006/main"/>
+          <a:p xmlns:a="http://schemas.openxmlformats.org/drawingml/2006/main">
+            <a:r>
+              <a:rPr lang="en-US" sz="3300" b="1">
+                <a:solidFill>
+                  <a:srgbClr val="1D4150"/>
+                </a:solidFill>
+                <a:latin typeface="Arial"/>
+                <a:ea typeface="Arial"/>
+              </a:rPr>
+              <a:t>Let the subject do the work</a:t>
+            </a:r>
+            <a:endParaRPr lang="en-US"/>
+          </a:p>
+        </p:txBody>
+      </p:sp>
+      <p:sp>
+        <p:nvSpPr>
+          <p:cNvPr id="5" name="visual-body"/>
+          <p:cNvSpPr txBox="1"/>
+          <p:nvPr/>
+        </p:nvSpPr>
+        <p:spPr>
+          <a:xfrm xmlns:a="http://schemas.openxmlformats.org/drawingml/2006/main">
+            <a:off x="914400" y="3219450"/>
+            <a:ext cx="4762500" cy="685800"/>
+          </a:xfrm>
+          <a:prstGeom xmlns:a="http://schemas.openxmlformats.org/drawingml/2006/main" prst="rect">
+            <a:avLst/>
+          </a:prstGeom>
+          <a:noFill xmlns:a="http://schemas.openxmlformats.org/drawingml/2006/main"/>
+          <a:ln xmlns:a="http://schemas.openxmlformats.org/drawingml/2006/main" w="0">
+            <a:noFill/>
+          </a:ln>
+        </p:spPr>
+        <p:txBody>
+          <a:bodyPr xmlns:a="http://schemas.openxmlformats.org/drawingml/2006/main" wrap="square" lIns="0" tIns="0" rIns="0" bIns="0" anchor="t"/>
+          <a:lstStyle xmlns:a="http://schemas.openxmlformats.org/drawingml/2006/main"/>
+          <a:p xmlns:a="http://schemas.openxmlformats.org/drawingml/2006/main">
+            <a:r>
+              <a:rPr lang="en-US" sz="1800">
+                <a:solidFill>
+                  <a:srgbClr val="1D4150"/>
+                </a:solidFill>
+                <a:latin typeface="Arial"/>
+                <a:ea typeface="Arial"/>
+              </a:rPr>
+              <a:t>A strong crop gives the proposition a place to live.</a:t>
+            </a:r>
+            <a:endParaRPr lang="en-US"/>
+          </a:p>
+        </p:txBody>
+      </p:sp>
+      <p:sp>
+        <p:nvSpPr>
+          <p:cNvPr id="6" name="visual-rule"/>
+          <p:cNvSpPr/>
+          <p:nvPr/>
+        </p:nvSpPr>
+        <p:spPr>
+          <a:xfrm xmlns:a="http://schemas.openxmlformats.org/drawingml/2006/main">
+            <a:off x="914400" y="4476750"/>
+            <a:ext cx="4419600" cy="0"/>
+          </a:xfrm>
+          <a:prstGeom xmlns:a="http://schemas.openxmlformats.org/drawingml/2006/main" prst="line">
+            <a:avLst/>
+          </a:prstGeom>
+          <a:noFill xmlns:a="http://schemas.openxmlformats.org/drawingml/2006/main"/>
+          <a:ln xmlns:a="http://schemas.openxmlformats.org/drawingml/2006/main" w="38100">
+            <a:solidFill>
+              <a:srgbClr val="0B8EA3"/>
+            </a:solidFill>
+            <a:prstDash val="solid"/>
+          </a:ln>
+        </p:spPr>
+        <p:txBody>
+          <a:bodyPr xmlns:a="http://schemas.openxmlformats.org/drawingml/2006/main" wrap="square" lIns="0" tIns="0" rIns="0" bIns="0" anchor="t"/>
+          <a:lstStyle xmlns:a="http://schemas.openxmlformats.org/drawingml/2006/main"/>
+          <a:p xmlns:a="http://schemas.openxmlformats.org/drawingml/2006/main">
+            <a:r>
+              <a:rPr lang="en-US"/>
+              <a:t/>
+            </a:r>
+            <a:endParaRPr lang="en-US"/>
+          </a:p>
+        </p:txBody>
+      </p:sp>
+      <p:sp>
+        <p:nvSpPr>
+          <p:cNvPr id="7" name="visual-label"/>
+          <p:cNvSpPr txBox="1"/>
+          <p:nvPr/>
+        </p:nvSpPr>
+        <p:spPr>
+          <a:xfrm xmlns:a="http://schemas.openxmlformats.org/drawingml/2006/main">
+            <a:off x="914400" y="4819650"/>
+            <a:ext cx="4953000" cy="228600"/>
+          </a:xfrm>
+          <a:prstGeom xmlns:a="http://schemas.openxmlformats.org/drawingml/2006/main" prst="rect">
+            <a:avLst/>
+          </a:prstGeom>
+          <a:noFill xmlns:a="http://schemas.openxmlformats.org/drawingml/2006/main"/>
+          <a:ln xmlns:a="http://schemas.openxmlformats.org/drawingml/2006/main" w="0">
+            <a:noFill/>
+          </a:ln>
+        </p:spPr>
+        <p:txBody>
+          <a:bodyPr xmlns:a="http://schemas.openxmlformats.org/drawingml/2006/main" wrap="square" lIns="0" tIns="0" rIns="0" bIns="0" anchor="t"/>
+          <a:lstStyle xmlns:a="http://schemas.openxmlformats.org/drawingml/2006/main"/>
+          <a:p xmlns:a="http://schemas.openxmlformats.org/drawingml/2006/main">
+            <a:r>
+              <a:rPr lang="en-US" sz="1200" b="1">
+                <a:solidFill>
+                  <a:srgbClr val="0B8EA3"/>
+                </a:solidFill>
+                <a:latin typeface="Arial"/>
+                <a:ea typeface="Arial"/>
+              </a:rPr>
+              <a:t>THE IMAGE IS EVIDENCE, NOT FILL</a:t>
+            </a:r>
+            <a:endParaRPr lang="en-US"/>
+          </a:p>
+        </p:txBody>
+      </p:sp>
+      <p:sp>
+        <p:nvSpPr>
+          <p:cNvPr id="8" name="source"/>
+          <p:cNvSpPr txBox="1"/>
+          <p:nvPr/>
+        </p:nvSpPr>
+        <p:spPr>
+          <a:xfrm xmlns:a="http://schemas.openxmlformats.org/drawingml/2006/main">
+            <a:off x="914400" y="7829550"/>
+            <a:ext cx="10953750" cy="209550"/>
+          </a:xfrm>
+          <a:prstGeom xmlns:a="http://schemas.openxmlformats.org/drawingml/2006/main" prst="rect">
+            <a:avLst/>
+          </a:prstGeom>
+          <a:noFill xmlns:a="http://schemas.openxmlformats.org/drawingml/2006/main"/>
+          <a:ln xmlns:a="http://schemas.openxmlformats.org/drawingml/2006/main" w="0">
+            <a:noFill/>
+          </a:ln>
+        </p:spPr>
+        <p:txBody>
+          <a:bodyPr xmlns:a="http://schemas.openxmlformats.org/drawingml/2006/main" wrap="square" lIns="0" tIns="0" rIns="0" bIns="0" anchor="t"/>
+          <a:lstStyle xmlns:a="http://schemas.openxmlformats.org/drawingml/2006/main"/>
+          <a:p xmlns:a="http://schemas.openxmlformats.org/drawingml/2006/main">
+            <a:r>
+              <a:rPr lang="en-US" sz="1050">
+                <a:solidFill>
+                  <a:srgbClr val="8C9B9D"/>
+                </a:solidFill>
+                <a:latin typeface="Arial"/>
+                <a:ea typeface="Arial"/>
+              </a:rPr>
+              <a:t>OfficeKit original clean-room visual field · fictional content</a:t>
+            </a:r>
+            <a:endParaRPr lang="en-US"/>
+          </a:p>
+        </p:txBody>
+      </p:sp>
+      <p:sp>
+        <p:nvSpPr>
+          <p:cNvPr id="9" name="page-number"/>
+          <p:cNvSpPr txBox="1"/>
+          <p:nvPr/>
+        </p:nvSpPr>
+        <p:spPr>
+          <a:xfrm xmlns:a="http://schemas.openxmlformats.org/drawingml/2006/main">
+            <a:off x="13335000" y="7829550"/>
+            <a:ext cx="952500" cy="209550"/>
+          </a:xfrm>
+          <a:prstGeom xmlns:a="http://schemas.openxmlformats.org/drawingml/2006/main" prst="rect">
+            <a:avLst/>
+          </a:prstGeom>
+          <a:noFill xmlns:a="http://schemas.openxmlformats.org/drawingml/2006/main"/>
+          <a:ln xmlns:a="http://schemas.openxmlformats.org/drawingml/2006/main" w="0">
+            <a:noFill/>
+          </a:ln>
+        </p:spPr>
+        <p:txBody>
+          <a:bodyPr xmlns:a="http://schemas.openxmlformats.org/drawingml/2006/main" wrap="square" lIns="0" tIns="0" rIns="0" bIns="0" anchor="t"/>
+          <a:lstStyle xmlns:a="http://schemas.openxmlformats.org/drawingml/2006/main"/>
+          <a:p xmlns:a="http://schemas.openxmlformats.org/drawingml/2006/main">
+            <a:pPr algn="r"/>
+            <a:r>
+              <a:rPr lang="en-US" sz="1050">
+                <a:solidFill>
+                  <a:srgbClr val="8C9B9D"/>
+                </a:solidFill>
+                <a:latin typeface="Arial"/>
+                <a:ea typeface="Arial"/>
+              </a:rPr>
+              <a:t>5 / 6</a:t>
+            </a:r>
+            <a:endParaRPr lang="en-US"/>
+          </a:p>
+        </p:txBody>
+      </p:sp>
+    </p:spTree>
+  </p:cSld>
+  <p:clrMapOvr>
+    <a:masterClrMapping xmlns:a="http://schemas.openxmlformats.org/drawingml/2006/main"/>
+  </p:clrMapOvr>
+</p:sld>
+</file>
+
+<file path=ppt/slides/slide6.xml><?xml version="1.0" encoding="utf-8"?>
+<p:sld xmlns:p="http://schemas.openxmlformats.org/presentationml/2006/main">
+  <p:cSld name="Decision close">
+    <p:bg>
+      <p:bgPr>
+        <a:blipFill xmlns:a="http://schemas.openxmlformats.org/drawingml/2006/main">
+          <a:blip xmlns:r="http://schemas.openxmlformats.org/officeDocument/2006/relationships" r:embed="rIdOfficeKitImagee231e9493e535fbe_1"/>
+          <a:stretch>
+            <a:fillRect/>
+          </a:stretch>
+        </a:blipFill>
+      </p:bgPr>
+    </p:bg>
+    <p:spTree>
+      <p:nvGrpSpPr>
+        <p:cNvPr id="1" name=""/>
+        <p:cNvGrpSpPr/>
+        <p:nvPr/>
+      </p:nvGrpSpPr>
+      <p:grpSpPr>
+        <a:xfrm xmlns:a="http://schemas.openxmlformats.org/drawingml/2006/main">
+          <a:off x="0" y="0"/>
+          <a:ext cx="0" cy="0"/>
+          <a:chOff x="0" y="0"/>
+          <a:chExt cx="0" cy="0"/>
+        </a:xfrm>
+      </p:grpSpPr>
+      <p:sp>
+        <p:nvSpPr>
           <p:cNvPr id="2" name="close-paper-scrim"/>
           <p:cNvSpPr/>
           <p:nvPr/>

</xml_diff>